<commit_message>
CORA_FHR_V1 official score 0.00 recorded (log, ledger, README, paper, explainer, review drafts); as predicted by its zero-commit rehearsal
</commit_message>
<xml_diff>
--- a/docs/summit_20261023_reframe/poster_review.pptx
+++ b/docs/summit_20261023_reframe/poster_review.pptx
@@ -14011,7 +14011,7 @@
         <p:spPr>
           <a:xfrm>
             <a:off x="20775738" y="29476027"/>
-            <a:ext cx="8620762" cy="312774"/>
+            <a:ext cx="8620659" cy="312774"/>
           </a:xfrm>
           <a:prstGeom prst="rect">
             <a:avLst/>
@@ -14031,7 +14031,25 @@
                 </a:solidFill>
                 <a:latin typeface="Arial"/>
               </a:rPr>
-              <a:t>which is</a:t>
+              <a:t>which</a:t>
+            </a:r>
+            <a:r>
+              <a:rPr sz="2460" b="0" i="0">
+                <a:solidFill>
+                  <a:srgbClr val="0B0B0B"/>
+                </a:solidFill>
+                <a:latin typeface="Arial"/>
+              </a:rPr>
+              <a:t> </a:t>
+            </a:r>
+            <a:r>
+              <a:rPr sz="2460" b="0" i="0">
+                <a:solidFill>
+                  <a:srgbClr val="0B0B0B"/>
+                </a:solidFill>
+                <a:latin typeface="Arial"/>
+              </a:rPr>
+              <a:t>is</a:t>
             </a:r>
             <a:r>
               <a:rPr sz="2460" b="1" i="0">
@@ -14040,16 +14058,151 @@
                 </a:solidFill>
                 <a:latin typeface="Arial"/>
               </a:rPr>
-              <a:t> not CORA</a:t>
-            </a:r>
-            <a:r>
-              <a:rPr sz="2460" b="0" i="0">
-                <a:solidFill>
-                  <a:srgbClr val="0B0B0B"/>
-                </a:solidFill>
-                <a:latin typeface="Arial"/>
-              </a:rPr>
-              <a:t>. A CORA-FHR research entry was submit-</a:t>
+              <a:t> </a:t>
+            </a:r>
+            <a:r>
+              <a:rPr sz="2460" b="1" i="0">
+                <a:solidFill>
+                  <a:srgbClr val="0B0B0B"/>
+                </a:solidFill>
+                <a:latin typeface="Arial"/>
+              </a:rPr>
+              <a:t>not</a:t>
+            </a:r>
+            <a:r>
+              <a:rPr sz="2460" b="1" i="0">
+                <a:solidFill>
+                  <a:srgbClr val="0B0B0B"/>
+                </a:solidFill>
+                <a:latin typeface="Arial"/>
+              </a:rPr>
+              <a:t> </a:t>
+            </a:r>
+            <a:r>
+              <a:rPr sz="2460" b="1" i="0">
+                <a:solidFill>
+                  <a:srgbClr val="0B0B0B"/>
+                </a:solidFill>
+                <a:latin typeface="Arial"/>
+              </a:rPr>
+              <a:t>CORA</a:t>
+            </a:r>
+            <a:r>
+              <a:rPr sz="2460" b="0" i="0">
+                <a:solidFill>
+                  <a:srgbClr val="0B0B0B"/>
+                </a:solidFill>
+                <a:latin typeface="Arial"/>
+              </a:rPr>
+              <a:t>.</a:t>
+            </a:r>
+            <a:r>
+              <a:rPr sz="2460" b="0" i="0">
+                <a:solidFill>
+                  <a:srgbClr val="0B0B0B"/>
+                </a:solidFill>
+                <a:latin typeface="Arial"/>
+              </a:rPr>
+              <a:t> </a:t>
+            </a:r>
+            <a:r>
+              <a:rPr sz="2460" b="0" i="0">
+                <a:solidFill>
+                  <a:srgbClr val="0B0B0B"/>
+                </a:solidFill>
+                <a:latin typeface="Arial"/>
+              </a:rPr>
+              <a:t>The</a:t>
+            </a:r>
+            <a:r>
+              <a:rPr sz="2460" b="0" i="0">
+                <a:solidFill>
+                  <a:srgbClr val="0B0B0B"/>
+                </a:solidFill>
+                <a:latin typeface="Arial"/>
+              </a:rPr>
+              <a:t> </a:t>
+            </a:r>
+            <a:r>
+              <a:rPr sz="2460" b="0" i="0">
+                <a:solidFill>
+                  <a:srgbClr val="0B0B0B"/>
+                </a:solidFill>
+                <a:latin typeface="Arial"/>
+              </a:rPr>
+              <a:t>CORA-FHR</a:t>
+            </a:r>
+            <a:r>
+              <a:rPr sz="2460" b="0" i="0">
+                <a:solidFill>
+                  <a:srgbClr val="0B0B0B"/>
+                </a:solidFill>
+                <a:latin typeface="Arial"/>
+              </a:rPr>
+              <a:t> </a:t>
+            </a:r>
+            <a:r>
+              <a:rPr sz="2460" b="0" i="0">
+                <a:solidFill>
+                  <a:srgbClr val="0B0B0B"/>
+                </a:solidFill>
+                <a:latin typeface="Arial"/>
+              </a:rPr>
+              <a:t>research</a:t>
+            </a:r>
+            <a:r>
+              <a:rPr sz="2460" b="0" i="0">
+                <a:solidFill>
+                  <a:srgbClr val="0B0B0B"/>
+                </a:solidFill>
+                <a:latin typeface="Arial"/>
+              </a:rPr>
+              <a:t> </a:t>
+            </a:r>
+            <a:r>
+              <a:rPr sz="2460" b="0" i="0">
+                <a:solidFill>
+                  <a:srgbClr val="0B0B0B"/>
+                </a:solidFill>
+                <a:latin typeface="Arial"/>
+              </a:rPr>
+              <a:t>entry</a:t>
+            </a:r>
+            <a:r>
+              <a:rPr sz="2460" b="0" i="0">
+                <a:solidFill>
+                  <a:srgbClr val="0B0B0B"/>
+                </a:solidFill>
+                <a:latin typeface="Arial"/>
+              </a:rPr>
+              <a:t> </a:t>
+            </a:r>
+            <a:r>
+              <a:rPr sz="2460" b="0" i="0">
+                <a:solidFill>
+                  <a:srgbClr val="0B0B0B"/>
+                </a:solidFill>
+                <a:latin typeface="Arial"/>
+              </a:rPr>
+              <a:t>(18</a:t>
+            </a:r>
+            <a:r>
+              <a:rPr sz="2460" b="0" i="0">
+                <a:solidFill>
+                  <a:srgbClr val="0B0B0B"/>
+                </a:solidFill>
+                <a:latin typeface="Arial"/>
+              </a:rPr>
+              <a:t> </a:t>
+            </a:r>
+            <a:r>
+              <a:rPr sz="2460" b="0" i="0">
+                <a:solidFill>
+                  <a:srgbClr val="0B0B0B"/>
+                </a:solidFill>
+                <a:latin typeface="Arial"/>
+              </a:rPr>
+              <a:t>Oc-</a:t>
             </a:r>
           </a:p>
         </p:txBody>
@@ -14062,8 +14215,8 @@
         </p:nvSpPr>
         <p:spPr>
           <a:xfrm>
-            <a:off x="20775739" y="29880901"/>
-            <a:ext cx="8620652" cy="312517"/>
+            <a:off x="20775738" y="29880901"/>
+            <a:ext cx="8620759" cy="312774"/>
           </a:xfrm>
           <a:prstGeom prst="rect">
             <a:avLst/>
@@ -14083,7 +14236,178 @@
                 </a:solidFill>
                 <a:latin typeface="Arial"/>
               </a:rPr>
-              <a:t>ted on 18 October; its score is pending, and its local rehearsal</a:t>
+              <a:t>tober)</a:t>
+            </a:r>
+            <a:r>
+              <a:rPr sz="2460" b="0" i="0">
+                <a:solidFill>
+                  <a:srgbClr val="0B0B0B"/>
+                </a:solidFill>
+                <a:latin typeface="Arial"/>
+              </a:rPr>
+              <a:t> </a:t>
+            </a:r>
+            <a:r>
+              <a:rPr sz="2460" b="0" i="0">
+                <a:solidFill>
+                  <a:srgbClr val="0B0B0B"/>
+                </a:solidFill>
+                <a:latin typeface="Arial"/>
+              </a:rPr>
+              <a:t>scored</a:t>
+            </a:r>
+            <a:r>
+              <a:rPr sz="2460" b="1" i="0">
+                <a:solidFill>
+                  <a:srgbClr val="0B0B0B"/>
+                </a:solidFill>
+                <a:latin typeface="Arial"/>
+              </a:rPr>
+              <a:t> </a:t>
+            </a:r>
+            <a:r>
+              <a:rPr sz="2460" b="1" i="0">
+                <a:solidFill>
+                  <a:srgbClr val="0B0B0B"/>
+                </a:solidFill>
+                <a:latin typeface="Arial"/>
+              </a:rPr>
+              <a:t>0.00</a:t>
+            </a:r>
+            <a:r>
+              <a:rPr sz="2460" b="0" i="0">
+                <a:solidFill>
+                  <a:srgbClr val="0B0B0B"/>
+                </a:solidFill>
+                <a:latin typeface="Arial"/>
+              </a:rPr>
+              <a:t>,</a:t>
+            </a:r>
+            <a:r>
+              <a:rPr sz="2460" b="0" i="0">
+                <a:solidFill>
+                  <a:srgbClr val="0B0B0B"/>
+                </a:solidFill>
+                <a:latin typeface="Arial"/>
+              </a:rPr>
+              <a:t> </a:t>
+            </a:r>
+            <a:r>
+              <a:rPr sz="2460" b="0" i="0">
+                <a:solidFill>
+                  <a:srgbClr val="0B0B0B"/>
+                </a:solidFill>
+                <a:latin typeface="Arial"/>
+              </a:rPr>
+              <a:t>as</a:t>
+            </a:r>
+            <a:r>
+              <a:rPr sz="2460" b="0" i="0">
+                <a:solidFill>
+                  <a:srgbClr val="0B0B0B"/>
+                </a:solidFill>
+                <a:latin typeface="Arial"/>
+              </a:rPr>
+              <a:t> </a:t>
+            </a:r>
+            <a:r>
+              <a:rPr sz="2460" b="0" i="0">
+                <a:solidFill>
+                  <a:srgbClr val="0B0B0B"/>
+                </a:solidFill>
+                <a:latin typeface="Arial"/>
+              </a:rPr>
+              <a:t>its</a:t>
+            </a:r>
+            <a:r>
+              <a:rPr sz="2460" b="0" i="0">
+                <a:solidFill>
+                  <a:srgbClr val="0B0B0B"/>
+                </a:solidFill>
+                <a:latin typeface="Arial"/>
+              </a:rPr>
+              <a:t> </a:t>
+            </a:r>
+            <a:r>
+              <a:rPr sz="2460" b="0" i="0">
+                <a:solidFill>
+                  <a:srgbClr val="0B0B0B"/>
+                </a:solidFill>
+                <a:latin typeface="Arial"/>
+              </a:rPr>
+              <a:t>local</a:t>
+            </a:r>
+            <a:r>
+              <a:rPr sz="2460" b="0" i="0">
+                <a:solidFill>
+                  <a:srgbClr val="0B0B0B"/>
+                </a:solidFill>
+                <a:latin typeface="Arial"/>
+              </a:rPr>
+              <a:t> </a:t>
+            </a:r>
+            <a:r>
+              <a:rPr sz="2460" b="0" i="0">
+                <a:solidFill>
+                  <a:srgbClr val="0B0B0B"/>
+                </a:solidFill>
+                <a:latin typeface="Arial"/>
+              </a:rPr>
+              <a:t>rehearsal</a:t>
+            </a:r>
+            <a:r>
+              <a:rPr sz="2460" b="0" i="0">
+                <a:solidFill>
+                  <a:srgbClr val="0B0B0B"/>
+                </a:solidFill>
+                <a:latin typeface="Arial"/>
+              </a:rPr>
+              <a:t> </a:t>
+            </a:r>
+            <a:r>
+              <a:rPr sz="2460" b="0" i="0">
+                <a:solidFill>
+                  <a:srgbClr val="0B0B0B"/>
+                </a:solidFill>
+                <a:latin typeface="Arial"/>
+              </a:rPr>
+              <a:t>predicted</a:t>
+            </a:r>
+            <a:r>
+              <a:rPr sz="2460" b="0" i="0">
+                <a:solidFill>
+                  <a:srgbClr val="0B0B0B"/>
+                </a:solidFill>
+                <a:latin typeface="Arial"/>
+              </a:rPr>
+              <a:t> </a:t>
+            </a:r>
+            <a:r>
+              <a:rPr sz="2460" b="0" i="0">
+                <a:solidFill>
+                  <a:srgbClr val="0B0B0B"/>
+                </a:solidFill>
+                <a:latin typeface="Arial"/>
+              </a:rPr>
+              <a:t>(no</a:t>
+            </a:r>
+            <a:r>
+              <a:rPr sz="2460" b="0" i="0">
+                <a:solidFill>
+                  <a:srgbClr val="0B0B0B"/>
+                </a:solidFill>
+                <a:latin typeface="Arial"/>
+              </a:rPr>
+              <a:t> </a:t>
+            </a:r>
+            <a:r>
+              <a:rPr sz="2460" b="0" i="0">
+                <a:solidFill>
+                  <a:srgbClr val="0B0B0B"/>
+                </a:solidFill>
+                <a:latin typeface="Arial"/>
+              </a:rPr>
+              <a:t>new</a:t>
             </a:r>
           </a:p>
         </p:txBody>
@@ -14117,25 +14441,169 @@
                 </a:solidFill>
                 <a:latin typeface="Arial"/>
               </a:rPr>
-              <a:t>committed no new answer.</a:t>
-            </a:r>
-            <a:r>
-              <a:rPr sz="2460" b="0" i="0">
-                <a:solidFill>
-                  <a:srgbClr val="0B0B0B"/>
-                </a:solidFill>
-                <a:latin typeface="Arial"/>
-              </a:rPr>
-              <a:t> </a:t>
-            </a:r>
-            <a:r>
-              <a:rPr sz="2460" b="0" i="0">
-                <a:solidFill>
-                  <a:srgbClr val="0B0B0B"/>
-                </a:solidFill>
-                <a:latin typeface="Arial"/>
-              </a:rPr>
-              <a:t>The guarded rule came later and is</a:t>
+              <a:t>answer</a:t>
+            </a:r>
+            <a:r>
+              <a:rPr sz="2460" b="0" i="0">
+                <a:solidFill>
+                  <a:srgbClr val="0B0B0B"/>
+                </a:solidFill>
+                <a:latin typeface="Arial"/>
+              </a:rPr>
+              <a:t> </a:t>
+            </a:r>
+            <a:r>
+              <a:rPr sz="2460" b="0" i="0">
+                <a:solidFill>
+                  <a:srgbClr val="0B0B0B"/>
+                </a:solidFill>
+                <a:latin typeface="Arial"/>
+              </a:rPr>
+              <a:t>committed).</a:t>
+            </a:r>
+            <a:r>
+              <a:rPr sz="2460" b="0" i="0">
+                <a:solidFill>
+                  <a:srgbClr val="0B0B0B"/>
+                </a:solidFill>
+                <a:latin typeface="Arial"/>
+              </a:rPr>
+              <a:t> </a:t>
+            </a:r>
+            <a:r>
+              <a:rPr sz="2460" b="0" i="0">
+                <a:solidFill>
+                  <a:srgbClr val="0B0B0B"/>
+                </a:solidFill>
+                <a:latin typeface="Arial"/>
+              </a:rPr>
+              <a:t>The</a:t>
+            </a:r>
+            <a:r>
+              <a:rPr sz="2460" b="0" i="0">
+                <a:solidFill>
+                  <a:srgbClr val="0B0B0B"/>
+                </a:solidFill>
+                <a:latin typeface="Arial"/>
+              </a:rPr>
+              <a:t> </a:t>
+            </a:r>
+            <a:r>
+              <a:rPr sz="2460" b="0" i="0">
+                <a:solidFill>
+                  <a:srgbClr val="0B0B0B"/>
+                </a:solidFill>
+                <a:latin typeface="Arial"/>
+              </a:rPr>
+              <a:t>guarded</a:t>
+            </a:r>
+            <a:r>
+              <a:rPr sz="2460" b="0" i="0">
+                <a:solidFill>
+                  <a:srgbClr val="0B0B0B"/>
+                </a:solidFill>
+                <a:latin typeface="Arial"/>
+              </a:rPr>
+              <a:t> </a:t>
+            </a:r>
+            <a:r>
+              <a:rPr sz="2460" b="0" i="0">
+                <a:solidFill>
+                  <a:srgbClr val="0B0B0B"/>
+                </a:solidFill>
+                <a:latin typeface="Arial"/>
+              </a:rPr>
+              <a:t>rule</a:t>
+            </a:r>
+            <a:r>
+              <a:rPr sz="2460" b="0" i="0">
+                <a:solidFill>
+                  <a:srgbClr val="0B0B0B"/>
+                </a:solidFill>
+                <a:latin typeface="Arial"/>
+              </a:rPr>
+              <a:t> </a:t>
+            </a:r>
+            <a:r>
+              <a:rPr sz="2460" b="0" i="0">
+                <a:solidFill>
+                  <a:srgbClr val="0B0B0B"/>
+                </a:solidFill>
+                <a:latin typeface="Arial"/>
+              </a:rPr>
+              <a:t>came</a:t>
+            </a:r>
+            <a:r>
+              <a:rPr sz="2460" b="0" i="0">
+                <a:solidFill>
+                  <a:srgbClr val="0B0B0B"/>
+                </a:solidFill>
+                <a:latin typeface="Arial"/>
+              </a:rPr>
+              <a:t> </a:t>
+            </a:r>
+            <a:r>
+              <a:rPr sz="2460" b="0" i="0">
+                <a:solidFill>
+                  <a:srgbClr val="0B0B0B"/>
+                </a:solidFill>
+                <a:latin typeface="Arial"/>
+              </a:rPr>
+              <a:t>later</a:t>
+            </a:r>
+            <a:r>
+              <a:rPr sz="2460" b="0" i="0">
+                <a:solidFill>
+                  <a:srgbClr val="0B0B0B"/>
+                </a:solidFill>
+                <a:latin typeface="Arial"/>
+              </a:rPr>
+              <a:t> </a:t>
+            </a:r>
+            <a:r>
+              <a:rPr sz="2460" b="0" i="0">
+                <a:solidFill>
+                  <a:srgbClr val="0B0B0B"/>
+                </a:solidFill>
+                <a:latin typeface="Arial"/>
+              </a:rPr>
+              <a:t>and</a:t>
+            </a:r>
+            <a:r>
+              <a:rPr sz="2460" b="0" i="0">
+                <a:solidFill>
+                  <a:srgbClr val="0B0B0B"/>
+                </a:solidFill>
+                <a:latin typeface="Arial"/>
+              </a:rPr>
+              <a:t> </a:t>
+            </a:r>
+            <a:r>
+              <a:rPr sz="2460" b="0" i="0">
+                <a:solidFill>
+                  <a:srgbClr val="0B0B0B"/>
+                </a:solidFill>
+                <a:latin typeface="Arial"/>
+              </a:rPr>
+              <a:t>is</a:t>
+            </a:r>
+            <a:r>
+              <a:rPr sz="2460" b="0" i="0">
+                <a:solidFill>
+                  <a:srgbClr val="0B0B0B"/>
+                </a:solidFill>
+                <a:latin typeface="Arial"/>
+              </a:rPr>
+              <a:t> </a:t>
+            </a:r>
+            <a:r>
+              <a:rPr sz="2460" b="0" i="0">
+                <a:solidFill>
+                  <a:srgbClr val="0B0B0B"/>
+                </a:solidFill>
+                <a:latin typeface="Arial"/>
+              </a:rPr>
+              <a:t>not</a:t>
             </a:r>
           </a:p>
         </p:txBody>
@@ -14149,7 +14617,7 @@
         <p:spPr>
           <a:xfrm>
             <a:off x="20775739" y="30690666"/>
-            <a:ext cx="1800586" cy="312517"/>
+            <a:ext cx="1279306" cy="312517"/>
           </a:xfrm>
           <a:prstGeom prst="rect">
             <a:avLst/>
@@ -14169,7 +14637,7 @@
                 </a:solidFill>
                 <a:latin typeface="Arial"/>
               </a:rPr>
-              <a:t>not part of it.</a:t>
+              <a:t>part of it.</a:t>
             </a:r>
           </a:p>
         </p:txBody>

</xml_diff>

<commit_message>
Forensic expressibility ceiling: 56/58 pool tasks need operations outside G-grow (language reach is the bottleneck); recorded in ledger, README, paper and review drafts
</commit_message>
<xml_diff>
--- a/docs/summit_20261023_reframe/poster_review.pptx
+++ b/docs/summit_20261023_reframe/poster_review.pptx
@@ -3601,7 +3601,7 @@
         </p:nvSpPr>
         <p:spPr>
           <a:xfrm>
-            <a:off x="20413274" y="24202314"/>
+            <a:off x="20413274" y="24946145"/>
             <a:ext cx="9295048" cy="71999"/>
           </a:xfrm>
           <a:prstGeom prst="rect">
@@ -3644,7 +3644,7 @@
         </p:nvSpPr>
         <p:spPr>
           <a:xfrm>
-            <a:off x="20413274" y="29252807"/>
+            <a:off x="20413274" y="29996638"/>
             <a:ext cx="9295048" cy="71999"/>
           </a:xfrm>
           <a:prstGeom prst="rect">
@@ -3687,7 +3687,7 @@
         </p:nvSpPr>
         <p:spPr>
           <a:xfrm>
-            <a:off x="20413274" y="34005708"/>
+            <a:off x="20413274" y="34749535"/>
             <a:ext cx="9295048" cy="71999"/>
           </a:xfrm>
           <a:prstGeom prst="rect">
@@ -12735,7 +12735,7 @@
         </p:nvSpPr>
         <p:spPr>
           <a:xfrm>
-            <a:off x="20775739" y="19238745"/>
+            <a:off x="20775739" y="19238732"/>
             <a:ext cx="8620599" cy="312515"/>
           </a:xfrm>
           <a:prstGeom prst="rect">
@@ -13360,7 +13360,7 @@
         <p:spPr>
           <a:xfrm>
             <a:off x="20775739" y="20453385"/>
-            <a:ext cx="8620645" cy="312515"/>
+            <a:ext cx="8159371" cy="312515"/>
           </a:xfrm>
           <a:prstGeom prst="rect">
             <a:avLst/>
@@ -13508,24 +13508,6 @@
               </a:rPr>
               <a:t>advantage.</a:t>
             </a:r>
-            <a:r>
-              <a:rPr sz="2460" b="0" i="0">
-                <a:solidFill>
-                  <a:srgbClr val="0B0B0B"/>
-                </a:solidFill>
-                <a:latin typeface="Arial"/>
-              </a:rPr>
-              <a:t> </a:t>
-            </a:r>
-            <a:r>
-              <a:rPr sz="2460" b="0" i="0">
-                <a:solidFill>
-                  <a:srgbClr val="0B0B0B"/>
-                </a:solidFill>
-                <a:latin typeface="Arial"/>
-              </a:rPr>
-              <a:t>The</a:t>
-            </a:r>
           </a:p>
         </p:txBody>
       </p:sp>
@@ -13537,8 +13519,8 @@
         </p:nvSpPr>
         <p:spPr>
           <a:xfrm>
-            <a:off x="20775739" y="20858261"/>
-            <a:ext cx="8620652" cy="312515"/>
+            <a:off x="29137136" y="20453385"/>
+            <a:ext cx="259249" cy="312515"/>
           </a:xfrm>
           <a:prstGeom prst="rect">
             <a:avLst/>
@@ -13558,151 +13540,7 @@
                 </a:solidFill>
                 <a:latin typeface="Arial"/>
               </a:rPr>
-              <a:t>bottleneck</a:t>
-            </a:r>
-            <a:r>
-              <a:rPr sz="2460" b="0" i="0">
-                <a:solidFill>
-                  <a:srgbClr val="0B0B0B"/>
-                </a:solidFill>
-                <a:latin typeface="Arial"/>
-              </a:rPr>
-              <a:t> </a:t>
-            </a:r>
-            <a:r>
-              <a:rPr sz="2460" b="0" i="0">
-                <a:solidFill>
-                  <a:srgbClr val="0B0B0B"/>
-                </a:solidFill>
-                <a:latin typeface="Arial"/>
-              </a:rPr>
-              <a:t>is</a:t>
-            </a:r>
-            <a:r>
-              <a:rPr sz="2460" b="0" i="0">
-                <a:solidFill>
-                  <a:srgbClr val="0B0B0B"/>
-                </a:solidFill>
-                <a:latin typeface="Arial"/>
-              </a:rPr>
-              <a:t> </a:t>
-            </a:r>
-            <a:r>
-              <a:rPr sz="2460" b="0" i="0">
-                <a:solidFill>
-                  <a:srgbClr val="0B0B0B"/>
-                </a:solidFill>
-                <a:latin typeface="Arial"/>
-              </a:rPr>
-              <a:t>upstream:</a:t>
-            </a:r>
-            <a:r>
-              <a:rPr sz="2460" b="0" i="0">
-                <a:solidFill>
-                  <a:srgbClr val="0B0B0B"/>
-                </a:solidFill>
-                <a:latin typeface="Arial"/>
-              </a:rPr>
-              <a:t> </a:t>
-            </a:r>
-            <a:r>
-              <a:rPr sz="2460" b="0" i="0">
-                <a:solidFill>
-                  <a:srgbClr val="0B0B0B"/>
-                </a:solidFill>
-                <a:latin typeface="Arial"/>
-              </a:rPr>
-              <a:t>usable</a:t>
-            </a:r>
-            <a:r>
-              <a:rPr sz="2460" b="0" i="0">
-                <a:solidFill>
-                  <a:srgbClr val="0B0B0B"/>
-                </a:solidFill>
-                <a:latin typeface="Arial"/>
-              </a:rPr>
-              <a:t> </a:t>
-            </a:r>
-            <a:r>
-              <a:rPr sz="2460" b="0" i="0">
-                <a:solidFill>
-                  <a:srgbClr val="0B0B0B"/>
-                </a:solidFill>
-                <a:latin typeface="Arial"/>
-              </a:rPr>
-              <a:t>evidence,</a:t>
-            </a:r>
-            <a:r>
-              <a:rPr sz="2460" b="0" i="0">
-                <a:solidFill>
-                  <a:srgbClr val="0B0B0B"/>
-                </a:solidFill>
-                <a:latin typeface="Arial"/>
-              </a:rPr>
-              <a:t> </a:t>
-            </a:r>
-            <a:r>
-              <a:rPr sz="2460" b="0" i="0">
-                <a:solidFill>
-                  <a:srgbClr val="0B0B0B"/>
-                </a:solidFill>
-                <a:latin typeface="Arial"/>
-              </a:rPr>
-              <a:t>and</a:t>
-            </a:r>
-            <a:r>
-              <a:rPr sz="2460" b="0" i="0">
-                <a:solidFill>
-                  <a:srgbClr val="0B0B0B"/>
-                </a:solidFill>
-                <a:latin typeface="Arial"/>
-              </a:rPr>
-              <a:t> </a:t>
-            </a:r>
-            <a:r>
-              <a:rPr sz="2460" b="0" i="0">
-                <a:solidFill>
-                  <a:srgbClr val="0B0B0B"/>
-                </a:solidFill>
-                <a:latin typeface="Arial"/>
-              </a:rPr>
-              <a:t>a</a:t>
-            </a:r>
-            <a:r>
-              <a:rPr sz="2460" b="0" i="0">
-                <a:solidFill>
-                  <a:srgbClr val="0B0B0B"/>
-                </a:solidFill>
-                <a:latin typeface="Arial"/>
-              </a:rPr>
-              <a:t> </a:t>
-            </a:r>
-            <a:r>
-              <a:rPr sz="2460" b="0" i="0">
-                <a:solidFill>
-                  <a:srgbClr val="0B0B0B"/>
-                </a:solidFill>
-                <a:latin typeface="Arial"/>
-              </a:rPr>
-              <a:t>language</a:t>
-            </a:r>
-            <a:r>
-              <a:rPr sz="2460" b="0" i="0">
-                <a:solidFill>
-                  <a:srgbClr val="0B0B0B"/>
-                </a:solidFill>
-                <a:latin typeface="Arial"/>
-              </a:rPr>
-              <a:t> </a:t>
-            </a:r>
-            <a:r>
-              <a:rPr sz="2460" b="0" i="0">
-                <a:solidFill>
-                  <a:srgbClr val="0B0B0B"/>
-                </a:solidFill>
-                <a:latin typeface="Arial"/>
-              </a:rPr>
-              <a:t>rich</a:t>
+              <a:t>A</a:t>
             </a:r>
           </a:p>
         </p:txBody>
@@ -13715,8 +13553,8 @@
         </p:nvSpPr>
         <p:spPr>
           <a:xfrm>
-            <a:off x="20775739" y="21263150"/>
-            <a:ext cx="4223222" cy="312515"/>
+            <a:off x="20775739" y="20858261"/>
+            <a:ext cx="8620636" cy="312515"/>
           </a:xfrm>
           <a:prstGeom prst="rect">
             <a:avLst/>
@@ -13736,7 +13574,25 @@
                 </a:solidFill>
                 <a:latin typeface="Arial"/>
               </a:rPr>
-              <a:t>enough for the transformation.</a:t>
+              <a:t>forensic check that reads the answers shows why:</a:t>
+            </a:r>
+            <a:r>
+              <a:rPr sz="2460" b="0" i="0">
+                <a:solidFill>
+                  <a:srgbClr val="0B0B0B"/>
+                </a:solidFill>
+                <a:latin typeface="Arial"/>
+              </a:rPr>
+              <a:t> </a:t>
+            </a:r>
+            <a:r>
+              <a:rPr sz="2460" b="0" i="0">
+                <a:solidFill>
+                  <a:srgbClr val="0B0B0B"/>
+                </a:solidFill>
+                <a:latin typeface="Arial"/>
+              </a:rPr>
+              <a:t>56 of the 58</a:t>
             </a:r>
           </a:p>
         </p:txBody>
@@ -13749,8 +13605,8 @@
         </p:nvSpPr>
         <p:spPr>
           <a:xfrm>
-            <a:off x="20775739" y="22816819"/>
-            <a:ext cx="7748336" cy="480795"/>
+            <a:off x="20775739" y="21263150"/>
+            <a:ext cx="8620645" cy="312515"/>
           </a:xfrm>
           <a:prstGeom prst="rect">
             <a:avLst/>
@@ -13764,31 +13620,31 @@
           <a:lstStyle/>
           <a:p>
             <a:r>
-              <a:rPr sz="3790" b="1" i="0">
-                <a:solidFill>
-                  <a:srgbClr val="2A78D6"/>
-                </a:solidFill>
-                <a:latin typeface="Arial"/>
-              </a:rPr>
-              <a:t>Scientific prediction</a:t>
-            </a:r>
-            <a:r>
-              <a:rPr sz="3790" b="1" i="0">
-                <a:solidFill>
-                  <a:srgbClr val="D03B3B"/>
-                </a:solidFill>
-                <a:latin typeface="Arial"/>
-              </a:rPr>
-              <a:t> </a:t>
-            </a:r>
-            <a:r>
-              <a:rPr sz="3790" b="1" i="0">
-                <a:solidFill>
-                  <a:srgbClr val="D03B3B"/>
-                </a:solidFill>
-                <a:latin typeface="Arial"/>
-              </a:rPr>
-              <a:t>PROPOSED,</a:t>
+              <a:rPr sz="2460" b="0" i="0">
+                <a:solidFill>
+                  <a:srgbClr val="0B0B0B"/>
+                </a:solidFill>
+                <a:latin typeface="Arial"/>
+              </a:rPr>
+              <a:t>need operations the grammar cannot express.</a:t>
+            </a:r>
+            <a:r>
+              <a:rPr sz="2460" b="0" i="0">
+                <a:solidFill>
+                  <a:srgbClr val="0B0B0B"/>
+                </a:solidFill>
+                <a:latin typeface="Arial"/>
+              </a:rPr>
+              <a:t> </a:t>
+            </a:r>
+            <a:r>
+              <a:rPr sz="2460" b="0" i="0">
+                <a:solidFill>
+                  <a:srgbClr val="0B0B0B"/>
+                </a:solidFill>
+                <a:latin typeface="Arial"/>
+              </a:rPr>
+              <a:t>The language’s</a:t>
             </a:r>
           </a:p>
         </p:txBody>
@@ -13801,8 +13657,8 @@
         </p:nvSpPr>
         <p:spPr>
           <a:xfrm>
-            <a:off x="20775739" y="23500053"/>
-            <a:ext cx="3076928" cy="480795"/>
+            <a:off x="20775739" y="21668026"/>
+            <a:ext cx="8620642" cy="312515"/>
           </a:xfrm>
           <a:prstGeom prst="rect">
             <a:avLst/>
@@ -13816,13 +13672,157 @@
           <a:lstStyle/>
           <a:p>
             <a:r>
-              <a:rPr sz="3790" b="1" i="0">
-                <a:solidFill>
-                  <a:srgbClr val="D03B3B"/>
-                </a:solidFill>
-                <a:latin typeface="Arial"/>
-              </a:rPr>
-              <a:t>NOT TESTED</a:t>
+              <a:rPr sz="2460" b="0" i="0">
+                <a:solidFill>
+                  <a:srgbClr val="0B0B0B"/>
+                </a:solidFill>
+                <a:latin typeface="Arial"/>
+              </a:rPr>
+              <a:t>reach</a:t>
+            </a:r>
+            <a:r>
+              <a:rPr sz="2460" b="0" i="0">
+                <a:solidFill>
+                  <a:srgbClr val="0B0B0B"/>
+                </a:solidFill>
+                <a:latin typeface="Arial"/>
+              </a:rPr>
+              <a:t> </a:t>
+            </a:r>
+            <a:r>
+              <a:rPr sz="2460" b="0" i="0">
+                <a:solidFill>
+                  <a:srgbClr val="0B0B0B"/>
+                </a:solidFill>
+                <a:latin typeface="Arial"/>
+              </a:rPr>
+              <a:t>is</a:t>
+            </a:r>
+            <a:r>
+              <a:rPr sz="2460" b="0" i="0">
+                <a:solidFill>
+                  <a:srgbClr val="0B0B0B"/>
+                </a:solidFill>
+                <a:latin typeface="Arial"/>
+              </a:rPr>
+              <a:t> </a:t>
+            </a:r>
+            <a:r>
+              <a:rPr sz="2460" b="0" i="0">
+                <a:solidFill>
+                  <a:srgbClr val="0B0B0B"/>
+                </a:solidFill>
+                <a:latin typeface="Arial"/>
+              </a:rPr>
+              <a:t>the</a:t>
+            </a:r>
+            <a:r>
+              <a:rPr sz="2460" b="0" i="0">
+                <a:solidFill>
+                  <a:srgbClr val="0B0B0B"/>
+                </a:solidFill>
+                <a:latin typeface="Arial"/>
+              </a:rPr>
+              <a:t> </a:t>
+            </a:r>
+            <a:r>
+              <a:rPr sz="2460" b="0" i="0">
+                <a:solidFill>
+                  <a:srgbClr val="0B0B0B"/>
+                </a:solidFill>
+                <a:latin typeface="Arial"/>
+              </a:rPr>
+              <a:t>bottleneck,</a:t>
+            </a:r>
+            <a:r>
+              <a:rPr sz="2460" b="0" i="0">
+                <a:solidFill>
+                  <a:srgbClr val="0B0B0B"/>
+                </a:solidFill>
+                <a:latin typeface="Arial"/>
+              </a:rPr>
+              <a:t> </a:t>
+            </a:r>
+            <a:r>
+              <a:rPr sz="2460" b="0" i="0">
+                <a:solidFill>
+                  <a:srgbClr val="0B0B0B"/>
+                </a:solidFill>
+                <a:latin typeface="Arial"/>
+              </a:rPr>
+              <a:t>which</a:t>
+            </a:r>
+            <a:r>
+              <a:rPr sz="2460" b="0" i="0">
+                <a:solidFill>
+                  <a:srgbClr val="0B0B0B"/>
+                </a:solidFill>
+                <a:latin typeface="Arial"/>
+              </a:rPr>
+              <a:t> </a:t>
+            </a:r>
+            <a:r>
+              <a:rPr sz="2460" b="0" i="0">
+                <a:solidFill>
+                  <a:srgbClr val="0B0B0B"/>
+                </a:solidFill>
+                <a:latin typeface="Arial"/>
+              </a:rPr>
+              <a:t>is</a:t>
+            </a:r>
+            <a:r>
+              <a:rPr sz="2460" b="0" i="0">
+                <a:solidFill>
+                  <a:srgbClr val="0B0B0B"/>
+                </a:solidFill>
+                <a:latin typeface="Arial"/>
+              </a:rPr>
+              <a:t> </a:t>
+            </a:r>
+            <a:r>
+              <a:rPr sz="2460" b="0" i="0">
+                <a:solidFill>
+                  <a:srgbClr val="0B0B0B"/>
+                </a:solidFill>
+                <a:latin typeface="Arial"/>
+              </a:rPr>
+              <a:t>the</a:t>
+            </a:r>
+            <a:r>
+              <a:rPr sz="2460" b="0" i="0">
+                <a:solidFill>
+                  <a:srgbClr val="0B0B0B"/>
+                </a:solidFill>
+                <a:latin typeface="Arial"/>
+              </a:rPr>
+              <a:t> </a:t>
+            </a:r>
+            <a:r>
+              <a:rPr sz="2460" b="0" i="0">
+                <a:solidFill>
+                  <a:srgbClr val="0B0B0B"/>
+                </a:solidFill>
+                <a:latin typeface="Arial"/>
+              </a:rPr>
+              <a:t>grammar-induction</a:t>
+            </a:r>
+            <a:r>
+              <a:rPr sz="2460" b="0" i="0">
+                <a:solidFill>
+                  <a:srgbClr val="0B0B0B"/>
+                </a:solidFill>
+                <a:latin typeface="Arial"/>
+              </a:rPr>
+              <a:t> </a:t>
+            </a:r>
+            <a:r>
+              <a:rPr sz="2460" b="0" i="0">
+                <a:solidFill>
+                  <a:srgbClr val="0B0B0B"/>
+                </a:solidFill>
+                <a:latin typeface="Arial"/>
+              </a:rPr>
+              <a:t>ques-</a:t>
             </a:r>
           </a:p>
         </p:txBody>
@@ -13835,8 +13835,8 @@
         </p:nvSpPr>
         <p:spPr>
           <a:xfrm>
-            <a:off x="20775739" y="24577864"/>
-            <a:ext cx="8620633" cy="312515"/>
+            <a:off x="20775739" y="22072914"/>
+            <a:ext cx="641458" cy="312515"/>
           </a:xfrm>
           <a:prstGeom prst="rect">
             <a:avLst/>
@@ -13856,133 +13856,7 @@
                 </a:solidFill>
                 <a:latin typeface="Arial"/>
               </a:rPr>
-              <a:t>With</a:t>
-            </a:r>
-            <a:r>
-              <a:rPr sz="2460" b="0" i="0">
-                <a:solidFill>
-                  <a:srgbClr val="0B0B0B"/>
-                </a:solidFill>
-                <a:latin typeface="Arial"/>
-              </a:rPr>
-              <a:t> </a:t>
-            </a:r>
-            <a:r>
-              <a:rPr sz="2460" b="0" i="0">
-                <a:solidFill>
-                  <a:srgbClr val="0B0B0B"/>
-                </a:solidFill>
-                <a:latin typeface="Arial"/>
-              </a:rPr>
-              <a:t>molecular</a:t>
-            </a:r>
-            <a:r>
-              <a:rPr sz="2460" b="0" i="0">
-                <a:solidFill>
-                  <a:srgbClr val="0B0B0B"/>
-                </a:solidFill>
-                <a:latin typeface="Arial"/>
-              </a:rPr>
-              <a:t> </a:t>
-            </a:r>
-            <a:r>
-              <a:rPr sz="2460" b="0" i="0">
-                <a:solidFill>
-                  <a:srgbClr val="0B0B0B"/>
-                </a:solidFill>
-                <a:latin typeface="Arial"/>
-              </a:rPr>
-              <a:t>measurements,</a:t>
-            </a:r>
-            <a:r>
-              <a:rPr sz="2460" b="0" i="0">
-                <a:solidFill>
-                  <a:srgbClr val="0B0B0B"/>
-                </a:solidFill>
-                <a:latin typeface="Arial"/>
-              </a:rPr>
-              <a:t> </a:t>
-            </a:r>
-            <a:r>
-              <a:rPr sz="2460" b="0" i="0">
-                <a:solidFill>
-                  <a:srgbClr val="0B0B0B"/>
-                </a:solidFill>
-                <a:latin typeface="Arial"/>
-              </a:rPr>
-              <a:t>should</a:t>
-            </a:r>
-            <a:r>
-              <a:rPr sz="2460" b="0" i="0">
-                <a:solidFill>
-                  <a:srgbClr val="0B0B0B"/>
-                </a:solidFill>
-                <a:latin typeface="Arial"/>
-              </a:rPr>
-              <a:t> </a:t>
-            </a:r>
-            <a:r>
-              <a:rPr sz="2460" b="0" i="0">
-                <a:solidFill>
-                  <a:srgbClr val="0B0B0B"/>
-                </a:solidFill>
-                <a:latin typeface="Arial"/>
-              </a:rPr>
-              <a:t>the</a:t>
-            </a:r>
-            <a:r>
-              <a:rPr sz="2460" b="0" i="0">
-                <a:solidFill>
-                  <a:srgbClr val="0B0B0B"/>
-                </a:solidFill>
-                <a:latin typeface="Arial"/>
-              </a:rPr>
-              <a:t> </a:t>
-            </a:r>
-            <a:r>
-              <a:rPr sz="2460" b="0" i="0">
-                <a:solidFill>
-                  <a:srgbClr val="0B0B0B"/>
-                </a:solidFill>
-                <a:latin typeface="Arial"/>
-              </a:rPr>
-              <a:t>system</a:t>
-            </a:r>
-            <a:r>
-              <a:rPr sz="2460" b="0" i="0">
-                <a:solidFill>
-                  <a:srgbClr val="0B0B0B"/>
-                </a:solidFill>
-                <a:latin typeface="Arial"/>
-              </a:rPr>
-              <a:t> </a:t>
-            </a:r>
-            <a:r>
-              <a:rPr sz="2460" b="0" i="0">
-                <a:solidFill>
-                  <a:srgbClr val="0B0B0B"/>
-                </a:solidFill>
-                <a:latin typeface="Arial"/>
-              </a:rPr>
-              <a:t>revise</a:t>
-            </a:r>
-            <a:r>
-              <a:rPr sz="2460" b="0" i="0">
-                <a:solidFill>
-                  <a:srgbClr val="0B0B0B"/>
-                </a:solidFill>
-                <a:latin typeface="Arial"/>
-              </a:rPr>
-              <a:t> </a:t>
-            </a:r>
-            <a:r>
-              <a:rPr sz="2460" b="0" i="0">
-                <a:solidFill>
-                  <a:srgbClr val="0B0B0B"/>
-                </a:solidFill>
-                <a:latin typeface="Arial"/>
-              </a:rPr>
-              <a:t>its</a:t>
+              <a:t>tion.</a:t>
             </a:r>
           </a:p>
         </p:txBody>
@@ -13995,8 +13869,8 @@
         </p:nvSpPr>
         <p:spPr>
           <a:xfrm>
-            <a:off x="20775739" y="24982740"/>
-            <a:ext cx="8620645" cy="312515"/>
+            <a:off x="20775739" y="23560634"/>
+            <a:ext cx="7748336" cy="480795"/>
           </a:xfrm>
           <a:prstGeom prst="rect">
             <a:avLst/>
@@ -14010,13 +13884,31 @@
           <a:lstStyle/>
           <a:p>
             <a:r>
-              <a:rPr sz="2460" b="0" i="0">
-                <a:solidFill>
-                  <a:srgbClr val="0B0B0B"/>
-                </a:solidFill>
-                <a:latin typeface="Arial"/>
-              </a:rPr>
-              <a:t>representation, revise its hypothesis, or ask for an experiment?</a:t>
+              <a:rPr sz="3790" b="1" i="0">
+                <a:solidFill>
+                  <a:srgbClr val="2A78D6"/>
+                </a:solidFill>
+                <a:latin typeface="Arial"/>
+              </a:rPr>
+              <a:t>Scientific prediction</a:t>
+            </a:r>
+            <a:r>
+              <a:rPr sz="3790" b="1" i="0">
+                <a:solidFill>
+                  <a:srgbClr val="D03B3B"/>
+                </a:solidFill>
+                <a:latin typeface="Arial"/>
+              </a:rPr>
+              <a:t> </a:t>
+            </a:r>
+            <a:r>
+              <a:rPr sz="3790" b="1" i="0">
+                <a:solidFill>
+                  <a:srgbClr val="D03B3B"/>
+                </a:solidFill>
+                <a:latin typeface="Arial"/>
+              </a:rPr>
+              <a:t>PROPOSED,</a:t>
             </a:r>
           </a:p>
         </p:txBody>
@@ -14029,8 +13921,8 @@
         </p:nvSpPr>
         <p:spPr>
           <a:xfrm>
-            <a:off x="20775739" y="25387628"/>
-            <a:ext cx="8620645" cy="312515"/>
+            <a:off x="20775739" y="24243881"/>
+            <a:ext cx="3076928" cy="480795"/>
           </a:xfrm>
           <a:prstGeom prst="rect">
             <a:avLst/>
@@ -14044,175 +13936,13 @@
           <a:lstStyle/>
           <a:p>
             <a:r>
-              <a:rPr sz="2460" b="0" i="0">
-                <a:solidFill>
-                  <a:srgbClr val="0B0B0B"/>
-                </a:solidFill>
-                <a:latin typeface="Arial"/>
-              </a:rPr>
-              <a:t>What</a:t>
-            </a:r>
-            <a:r>
-              <a:rPr sz="2460" b="0" i="0">
-                <a:solidFill>
-                  <a:srgbClr val="0B0B0B"/>
-                </a:solidFill>
-                <a:latin typeface="Arial"/>
-              </a:rPr>
-              <a:t> </a:t>
-            </a:r>
-            <a:r>
-              <a:rPr sz="2460" b="0" i="0">
-                <a:solidFill>
-                  <a:srgbClr val="0B0B0B"/>
-                </a:solidFill>
-                <a:latin typeface="Arial"/>
-              </a:rPr>
-              <a:t>could</a:t>
-            </a:r>
-            <a:r>
-              <a:rPr sz="2460" b="0" i="0">
-                <a:solidFill>
-                  <a:srgbClr val="0B0B0B"/>
-                </a:solidFill>
-                <a:latin typeface="Arial"/>
-              </a:rPr>
-              <a:t> </a:t>
-            </a:r>
-            <a:r>
-              <a:rPr sz="2460" b="0" i="0">
-                <a:solidFill>
-                  <a:srgbClr val="0B0B0B"/>
-                </a:solidFill>
-                <a:latin typeface="Arial"/>
-              </a:rPr>
-              <a:t>transfer</a:t>
-            </a:r>
-            <a:r>
-              <a:rPr sz="2460" b="0" i="0">
-                <a:solidFill>
-                  <a:srgbClr val="0B0B0B"/>
-                </a:solidFill>
-                <a:latin typeface="Arial"/>
-              </a:rPr>
-              <a:t> </a:t>
-            </a:r>
-            <a:r>
-              <a:rPr sz="2460" b="0" i="0">
-                <a:solidFill>
-                  <a:srgbClr val="0B0B0B"/>
-                </a:solidFill>
-                <a:latin typeface="Arial"/>
-              </a:rPr>
-              <a:t>is</a:t>
-            </a:r>
-            <a:r>
-              <a:rPr sz="2460" b="0" i="0">
-                <a:solidFill>
-                  <a:srgbClr val="0B0B0B"/>
-                </a:solidFill>
-                <a:latin typeface="Arial"/>
-              </a:rPr>
-              <a:t> </a:t>
-            </a:r>
-            <a:r>
-              <a:rPr sz="2460" b="0" i="0">
-                <a:solidFill>
-                  <a:srgbClr val="0B0B0B"/>
-                </a:solidFill>
-                <a:latin typeface="Arial"/>
-              </a:rPr>
-              <a:t>the</a:t>
-            </a:r>
-            <a:r>
-              <a:rPr sz="2460" b="0" i="0">
-                <a:solidFill>
-                  <a:srgbClr val="0B0B0B"/>
-                </a:solidFill>
-                <a:latin typeface="Arial"/>
-              </a:rPr>
-              <a:t> </a:t>
-            </a:r>
-            <a:r>
-              <a:rPr sz="2460" b="0" i="0">
-                <a:solidFill>
-                  <a:srgbClr val="0B0B0B"/>
-                </a:solidFill>
-                <a:latin typeface="Arial"/>
-              </a:rPr>
-              <a:t>revision</a:t>
-            </a:r>
-            <a:r>
-              <a:rPr sz="2460" b="0" i="0">
-                <a:solidFill>
-                  <a:srgbClr val="0B0B0B"/>
-                </a:solidFill>
-                <a:latin typeface="Arial"/>
-              </a:rPr>
-              <a:t> </a:t>
-            </a:r>
-            <a:r>
-              <a:rPr sz="2460" b="0" i="0">
-                <a:solidFill>
-                  <a:srgbClr val="0B0B0B"/>
-                </a:solidFill>
-                <a:latin typeface="Arial"/>
-              </a:rPr>
-              <a:t>policy</a:t>
-            </a:r>
-            <a:r>
-              <a:rPr sz="2460" b="0" i="0">
-                <a:solidFill>
-                  <a:srgbClr val="0B0B0B"/>
-                </a:solidFill>
-                <a:latin typeface="Arial"/>
-              </a:rPr>
-              <a:t> </a:t>
-            </a:r>
-            <a:r>
-              <a:rPr sz="2460" b="0" i="0">
-                <a:solidFill>
-                  <a:srgbClr val="0B0B0B"/>
-                </a:solidFill>
-                <a:latin typeface="Arial"/>
-              </a:rPr>
-              <a:t>and</a:t>
-            </a:r>
-            <a:r>
-              <a:rPr sz="2460" b="0" i="0">
-                <a:solidFill>
-                  <a:srgbClr val="0B0B0B"/>
-                </a:solidFill>
-                <a:latin typeface="Arial"/>
-              </a:rPr>
-              <a:t> </a:t>
-            </a:r>
-            <a:r>
-              <a:rPr sz="2460" b="0" i="0">
-                <a:solidFill>
-                  <a:srgbClr val="0B0B0B"/>
-                </a:solidFill>
-                <a:latin typeface="Arial"/>
-              </a:rPr>
-              <a:t>the</a:t>
-            </a:r>
-            <a:r>
-              <a:rPr sz="2460" b="0" i="0">
-                <a:solidFill>
-                  <a:srgbClr val="0B0B0B"/>
-                </a:solidFill>
-                <a:latin typeface="Arial"/>
-              </a:rPr>
-              <a:t> </a:t>
-            </a:r>
-            <a:r>
-              <a:rPr sz="2460" b="0" i="0">
-                <a:solidFill>
-                  <a:srgbClr val="0B0B0B"/>
-                </a:solidFill>
-                <a:latin typeface="Arial"/>
-              </a:rPr>
-              <a:t>verification</a:t>
+              <a:rPr sz="3790" b="1" i="0">
+                <a:solidFill>
+                  <a:srgbClr val="D03B3B"/>
+                </a:solidFill>
+                <a:latin typeface="Arial"/>
+              </a:rPr>
+              <a:t>NOT TESTED</a:t>
             </a:r>
           </a:p>
         </p:txBody>
@@ -14225,8 +13955,8 @@
         </p:nvSpPr>
         <p:spPr>
           <a:xfrm>
-            <a:off x="20775739" y="25792506"/>
-            <a:ext cx="8620639" cy="312517"/>
+            <a:off x="20775739" y="25321677"/>
+            <a:ext cx="8620633" cy="312515"/>
           </a:xfrm>
           <a:prstGeom prst="rect">
             <a:avLst/>
@@ -14246,151 +13976,133 @@
                 </a:solidFill>
                 <a:latin typeface="Arial"/>
               </a:rPr>
-              <a:t>interface,</a:t>
-            </a:r>
-            <a:r>
-              <a:rPr sz="2460" b="0" i="0">
-                <a:solidFill>
-                  <a:srgbClr val="0B0B0B"/>
-                </a:solidFill>
-                <a:latin typeface="Arial"/>
-              </a:rPr>
-              <a:t> </a:t>
-            </a:r>
-            <a:r>
-              <a:rPr sz="2460" b="0" i="0">
-                <a:solidFill>
-                  <a:srgbClr val="0B0B0B"/>
-                </a:solidFill>
-                <a:latin typeface="Arial"/>
-              </a:rPr>
-              <a:t>not</a:t>
-            </a:r>
-            <a:r>
-              <a:rPr sz="2460" b="0" i="0">
-                <a:solidFill>
-                  <a:srgbClr val="0B0B0B"/>
-                </a:solidFill>
-                <a:latin typeface="Arial"/>
-              </a:rPr>
-              <a:t> </a:t>
-            </a:r>
-            <a:r>
-              <a:rPr sz="2460" b="0" i="0">
-                <a:solidFill>
-                  <a:srgbClr val="0B0B0B"/>
-                </a:solidFill>
-                <a:latin typeface="Arial"/>
-              </a:rPr>
-              <a:t>ARC</a:t>
-            </a:r>
-            <a:r>
-              <a:rPr sz="2460" b="0" i="0">
-                <a:solidFill>
-                  <a:srgbClr val="0B0B0B"/>
-                </a:solidFill>
-                <a:latin typeface="Arial"/>
-              </a:rPr>
-              <a:t> </a:t>
-            </a:r>
-            <a:r>
-              <a:rPr sz="2460" b="0" i="0">
-                <a:solidFill>
-                  <a:srgbClr val="0B0B0B"/>
-                </a:solidFill>
-                <a:latin typeface="Arial"/>
-              </a:rPr>
-              <a:t>operators.</a:t>
-            </a:r>
-            <a:r>
-              <a:rPr sz="2460" b="0" i="0">
-                <a:solidFill>
-                  <a:srgbClr val="0B0B0B"/>
-                </a:solidFill>
-                <a:latin typeface="Arial"/>
-              </a:rPr>
-              <a:t> </a:t>
-            </a:r>
-            <a:r>
-              <a:rPr sz="2460" b="0" i="0">
-                <a:solidFill>
-                  <a:srgbClr val="0B0B0B"/>
-                </a:solidFill>
-                <a:latin typeface="Arial"/>
-              </a:rPr>
-              <a:t>A</a:t>
-            </a:r>
-            <a:r>
-              <a:rPr sz="2460" b="0" i="0">
-                <a:solidFill>
-                  <a:srgbClr val="0B0B0B"/>
-                </a:solidFill>
-                <a:latin typeface="Arial"/>
-              </a:rPr>
-              <a:t> </a:t>
-            </a:r>
-            <a:r>
-              <a:rPr sz="2460" b="0" i="0">
-                <a:solidFill>
-                  <a:srgbClr val="0B0B0B"/>
-                </a:solidFill>
-                <a:latin typeface="Arial"/>
-              </a:rPr>
-              <a:t>biological</a:t>
-            </a:r>
-            <a:r>
-              <a:rPr sz="2460" b="0" i="0">
-                <a:solidFill>
-                  <a:srgbClr val="0B0B0B"/>
-                </a:solidFill>
-                <a:latin typeface="Arial"/>
-              </a:rPr>
-              <a:t> </a:t>
-            </a:r>
-            <a:r>
-              <a:rPr sz="2460" b="0" i="0">
-                <a:solidFill>
-                  <a:srgbClr val="0B0B0B"/>
-                </a:solidFill>
-                <a:latin typeface="Arial"/>
-              </a:rPr>
-              <a:t>check</a:t>
-            </a:r>
-            <a:r>
-              <a:rPr sz="2460" b="0" i="0">
-                <a:solidFill>
-                  <a:srgbClr val="0B0B0B"/>
-                </a:solidFill>
-                <a:latin typeface="Arial"/>
-              </a:rPr>
-              <a:t> </a:t>
-            </a:r>
-            <a:r>
-              <a:rPr sz="2460" b="0" i="0">
-                <a:solidFill>
-                  <a:srgbClr val="0B0B0B"/>
-                </a:solidFill>
-                <a:latin typeface="Arial"/>
-              </a:rPr>
-              <a:t>needs</a:t>
-            </a:r>
-            <a:r>
-              <a:rPr sz="2460" b="0" i="0">
-                <a:solidFill>
-                  <a:srgbClr val="0B0B0B"/>
-                </a:solidFill>
-                <a:latin typeface="Arial"/>
-              </a:rPr>
-              <a:t> </a:t>
-            </a:r>
-            <a:r>
-              <a:rPr sz="2460" b="0" i="0">
-                <a:solidFill>
-                  <a:srgbClr val="0B0B0B"/>
-                </a:solidFill>
-                <a:latin typeface="Arial"/>
-              </a:rPr>
-              <a:t>toler-</a:t>
+              <a:t>With</a:t>
+            </a:r>
+            <a:r>
+              <a:rPr sz="2460" b="0" i="0">
+                <a:solidFill>
+                  <a:srgbClr val="0B0B0B"/>
+                </a:solidFill>
+                <a:latin typeface="Arial"/>
+              </a:rPr>
+              <a:t> </a:t>
+            </a:r>
+            <a:r>
+              <a:rPr sz="2460" b="0" i="0">
+                <a:solidFill>
+                  <a:srgbClr val="0B0B0B"/>
+                </a:solidFill>
+                <a:latin typeface="Arial"/>
+              </a:rPr>
+              <a:t>molecular</a:t>
+            </a:r>
+            <a:r>
+              <a:rPr sz="2460" b="0" i="0">
+                <a:solidFill>
+                  <a:srgbClr val="0B0B0B"/>
+                </a:solidFill>
+                <a:latin typeface="Arial"/>
+              </a:rPr>
+              <a:t> </a:t>
+            </a:r>
+            <a:r>
+              <a:rPr sz="2460" b="0" i="0">
+                <a:solidFill>
+                  <a:srgbClr val="0B0B0B"/>
+                </a:solidFill>
+                <a:latin typeface="Arial"/>
+              </a:rPr>
+              <a:t>measurements,</a:t>
+            </a:r>
+            <a:r>
+              <a:rPr sz="2460" b="0" i="0">
+                <a:solidFill>
+                  <a:srgbClr val="0B0B0B"/>
+                </a:solidFill>
+                <a:latin typeface="Arial"/>
+              </a:rPr>
+              <a:t> </a:t>
+            </a:r>
+            <a:r>
+              <a:rPr sz="2460" b="0" i="0">
+                <a:solidFill>
+                  <a:srgbClr val="0B0B0B"/>
+                </a:solidFill>
+                <a:latin typeface="Arial"/>
+              </a:rPr>
+              <a:t>should</a:t>
+            </a:r>
+            <a:r>
+              <a:rPr sz="2460" b="0" i="0">
+                <a:solidFill>
+                  <a:srgbClr val="0B0B0B"/>
+                </a:solidFill>
+                <a:latin typeface="Arial"/>
+              </a:rPr>
+              <a:t> </a:t>
+            </a:r>
+            <a:r>
+              <a:rPr sz="2460" b="0" i="0">
+                <a:solidFill>
+                  <a:srgbClr val="0B0B0B"/>
+                </a:solidFill>
+                <a:latin typeface="Arial"/>
+              </a:rPr>
+              <a:t>the</a:t>
+            </a:r>
+            <a:r>
+              <a:rPr sz="2460" b="0" i="0">
+                <a:solidFill>
+                  <a:srgbClr val="0B0B0B"/>
+                </a:solidFill>
+                <a:latin typeface="Arial"/>
+              </a:rPr>
+              <a:t> </a:t>
+            </a:r>
+            <a:r>
+              <a:rPr sz="2460" b="0" i="0">
+                <a:solidFill>
+                  <a:srgbClr val="0B0B0B"/>
+                </a:solidFill>
+                <a:latin typeface="Arial"/>
+              </a:rPr>
+              <a:t>system</a:t>
+            </a:r>
+            <a:r>
+              <a:rPr sz="2460" b="0" i="0">
+                <a:solidFill>
+                  <a:srgbClr val="0B0B0B"/>
+                </a:solidFill>
+                <a:latin typeface="Arial"/>
+              </a:rPr>
+              <a:t> </a:t>
+            </a:r>
+            <a:r>
+              <a:rPr sz="2460" b="0" i="0">
+                <a:solidFill>
+                  <a:srgbClr val="0B0B0B"/>
+                </a:solidFill>
+                <a:latin typeface="Arial"/>
+              </a:rPr>
+              <a:t>revise</a:t>
+            </a:r>
+            <a:r>
+              <a:rPr sz="2460" b="0" i="0">
+                <a:solidFill>
+                  <a:srgbClr val="0B0B0B"/>
+                </a:solidFill>
+                <a:latin typeface="Arial"/>
+              </a:rPr>
+              <a:t> </a:t>
+            </a:r>
+            <a:r>
+              <a:rPr sz="2460" b="0" i="0">
+                <a:solidFill>
+                  <a:srgbClr val="0B0B0B"/>
+                </a:solidFill>
+                <a:latin typeface="Arial"/>
+              </a:rPr>
+              <a:t>its</a:t>
             </a:r>
           </a:p>
         </p:txBody>
@@ -14403,8 +14115,8 @@
         </p:nvSpPr>
         <p:spPr>
           <a:xfrm>
-            <a:off x="20775739" y="26197393"/>
-            <a:ext cx="8620639" cy="312517"/>
+            <a:off x="20775739" y="25726566"/>
+            <a:ext cx="8620645" cy="312517"/>
           </a:xfrm>
           <a:prstGeom prst="rect">
             <a:avLst/>
@@ -14424,7 +14136,7 @@
                 </a:solidFill>
                 <a:latin typeface="Arial"/>
               </a:rPr>
-              <a:t>ance, real replicates, held-out conditions and experiments, not</a:t>
+              <a:t>representation, revise its hypothesis, or ask for an experiment?</a:t>
             </a:r>
           </a:p>
         </p:txBody>
@@ -14437,7 +14149,7 @@
         </p:nvSpPr>
         <p:spPr>
           <a:xfrm>
-            <a:off x="20775739" y="26602267"/>
+            <a:off x="20775739" y="26131443"/>
             <a:ext cx="8620645" cy="312517"/>
           </a:xfrm>
           <a:prstGeom prst="rect">
@@ -14458,133 +14170,115 @@
                 </a:solidFill>
                 <a:latin typeface="Arial"/>
               </a:rPr>
-              <a:t>exact</a:t>
-            </a:r>
-            <a:r>
-              <a:rPr sz="2460" b="0" i="0">
-                <a:solidFill>
-                  <a:srgbClr val="0B0B0B"/>
-                </a:solidFill>
-                <a:latin typeface="Arial"/>
-              </a:rPr>
-              <a:t> </a:t>
-            </a:r>
-            <a:r>
-              <a:rPr sz="2460" b="0" i="0">
-                <a:solidFill>
-                  <a:srgbClr val="0B0B0B"/>
-                </a:solidFill>
-                <a:latin typeface="Arial"/>
-              </a:rPr>
-              <a:t>match.</a:t>
-            </a:r>
-            <a:r>
-              <a:rPr sz="2460" b="0" i="0">
-                <a:solidFill>
-                  <a:srgbClr val="0B0B0B"/>
-                </a:solidFill>
-                <a:latin typeface="Arial"/>
-              </a:rPr>
-              <a:t> </a:t>
-            </a:r>
-            <a:r>
-              <a:rPr sz="2460" b="0" i="0">
-                <a:solidFill>
-                  <a:srgbClr val="0B0B0B"/>
-                </a:solidFill>
-                <a:latin typeface="Arial"/>
-              </a:rPr>
-              <a:t>The</a:t>
-            </a:r>
-            <a:r>
-              <a:rPr sz="2460" b="0" i="0">
-                <a:solidFill>
-                  <a:srgbClr val="0B0B0B"/>
-                </a:solidFill>
-                <a:latin typeface="Arial"/>
-              </a:rPr>
-              <a:t> </a:t>
-            </a:r>
-            <a:r>
-              <a:rPr sz="2460" b="0" i="0">
-                <a:solidFill>
-                  <a:srgbClr val="0B0B0B"/>
-                </a:solidFill>
-                <a:latin typeface="Arial"/>
-              </a:rPr>
-              <a:t>problem</a:t>
-            </a:r>
-            <a:r>
-              <a:rPr sz="2460" b="0" i="0">
-                <a:solidFill>
-                  <a:srgbClr val="0B0B0B"/>
-                </a:solidFill>
-                <a:latin typeface="Arial"/>
-              </a:rPr>
-              <a:t> </a:t>
-            </a:r>
-            <a:r>
-              <a:rPr sz="2460" b="0" i="0">
-                <a:solidFill>
-                  <a:srgbClr val="0B0B0B"/>
-                </a:solidFill>
-                <a:latin typeface="Arial"/>
-              </a:rPr>
-              <a:t>contract</a:t>
-            </a:r>
-            <a:r>
-              <a:rPr sz="2460" b="0" i="0">
-                <a:solidFill>
-                  <a:srgbClr val="0B0B0B"/>
-                </a:solidFill>
-                <a:latin typeface="Arial"/>
-              </a:rPr>
-              <a:t> </a:t>
-            </a:r>
-            <a:r>
-              <a:rPr sz="2460" b="0" i="0">
-                <a:solidFill>
-                  <a:srgbClr val="0B0B0B"/>
-                </a:solidFill>
-                <a:latin typeface="Arial"/>
-              </a:rPr>
-              <a:t>(questions</a:t>
-            </a:r>
-            <a:r>
-              <a:rPr sz="2460" b="0" i="0">
-                <a:solidFill>
-                  <a:srgbClr val="0B0B0B"/>
-                </a:solidFill>
-                <a:latin typeface="Arial"/>
-              </a:rPr>
-              <a:t> </a:t>
-            </a:r>
-            <a:r>
-              <a:rPr sz="2460" b="0" i="0">
-                <a:solidFill>
-                  <a:srgbClr val="0B0B0B"/>
-                </a:solidFill>
-                <a:latin typeface="Arial"/>
-              </a:rPr>
-              <a:t>for</a:t>
-            </a:r>
-            <a:r>
-              <a:rPr sz="2460" b="0" i="0">
-                <a:solidFill>
-                  <a:srgbClr val="0B0B0B"/>
-                </a:solidFill>
-                <a:latin typeface="Arial"/>
-              </a:rPr>
-              <a:t> </a:t>
-            </a:r>
-            <a:r>
-              <a:rPr sz="2460" b="0" i="0">
-                <a:solidFill>
-                  <a:srgbClr val="0B0B0B"/>
-                </a:solidFill>
-                <a:latin typeface="Arial"/>
-              </a:rPr>
-              <a:t>Pierce</a:t>
+              <a:t>What</a:t>
+            </a:r>
+            <a:r>
+              <a:rPr sz="2460" b="0" i="0">
+                <a:solidFill>
+                  <a:srgbClr val="0B0B0B"/>
+                </a:solidFill>
+                <a:latin typeface="Arial"/>
+              </a:rPr>
+              <a:t> </a:t>
+            </a:r>
+            <a:r>
+              <a:rPr sz="2460" b="0" i="0">
+                <a:solidFill>
+                  <a:srgbClr val="0B0B0B"/>
+                </a:solidFill>
+                <a:latin typeface="Arial"/>
+              </a:rPr>
+              <a:t>could</a:t>
+            </a:r>
+            <a:r>
+              <a:rPr sz="2460" b="0" i="0">
+                <a:solidFill>
+                  <a:srgbClr val="0B0B0B"/>
+                </a:solidFill>
+                <a:latin typeface="Arial"/>
+              </a:rPr>
+              <a:t> </a:t>
+            </a:r>
+            <a:r>
+              <a:rPr sz="2460" b="0" i="0">
+                <a:solidFill>
+                  <a:srgbClr val="0B0B0B"/>
+                </a:solidFill>
+                <a:latin typeface="Arial"/>
+              </a:rPr>
+              <a:t>transfer</a:t>
+            </a:r>
+            <a:r>
+              <a:rPr sz="2460" b="0" i="0">
+                <a:solidFill>
+                  <a:srgbClr val="0B0B0B"/>
+                </a:solidFill>
+                <a:latin typeface="Arial"/>
+              </a:rPr>
+              <a:t> </a:t>
+            </a:r>
+            <a:r>
+              <a:rPr sz="2460" b="0" i="0">
+                <a:solidFill>
+                  <a:srgbClr val="0B0B0B"/>
+                </a:solidFill>
+                <a:latin typeface="Arial"/>
+              </a:rPr>
+              <a:t>is</a:t>
+            </a:r>
+            <a:r>
+              <a:rPr sz="2460" b="0" i="0">
+                <a:solidFill>
+                  <a:srgbClr val="0B0B0B"/>
+                </a:solidFill>
+                <a:latin typeface="Arial"/>
+              </a:rPr>
+              <a:t> </a:t>
+            </a:r>
+            <a:r>
+              <a:rPr sz="2460" b="0" i="0">
+                <a:solidFill>
+                  <a:srgbClr val="0B0B0B"/>
+                </a:solidFill>
+                <a:latin typeface="Arial"/>
+              </a:rPr>
+              <a:t>the</a:t>
+            </a:r>
+            <a:r>
+              <a:rPr sz="2460" b="0" i="0">
+                <a:solidFill>
+                  <a:srgbClr val="0B0B0B"/>
+                </a:solidFill>
+                <a:latin typeface="Arial"/>
+              </a:rPr>
+              <a:t> </a:t>
+            </a:r>
+            <a:r>
+              <a:rPr sz="2460" b="0" i="0">
+                <a:solidFill>
+                  <a:srgbClr val="0B0B0B"/>
+                </a:solidFill>
+                <a:latin typeface="Arial"/>
+              </a:rPr>
+              <a:t>revision</a:t>
+            </a:r>
+            <a:r>
+              <a:rPr sz="2460" b="0" i="0">
+                <a:solidFill>
+                  <a:srgbClr val="0B0B0B"/>
+                </a:solidFill>
+                <a:latin typeface="Arial"/>
+              </a:rPr>
+              <a:t> </a:t>
+            </a:r>
+            <a:r>
+              <a:rPr sz="2460" b="0" i="0">
+                <a:solidFill>
+                  <a:srgbClr val="0B0B0B"/>
+                </a:solidFill>
+                <a:latin typeface="Arial"/>
+              </a:rPr>
+              <a:t>policy</a:t>
             </a:r>
             <a:r>
               <a:rPr sz="2460" b="0" i="0">
@@ -14603,6 +14297,42 @@
                 <a:latin typeface="Arial"/>
               </a:rPr>
               <a:t>and</a:t>
+            </a:r>
+            <a:r>
+              <a:rPr sz="2460" b="0" i="0">
+                <a:solidFill>
+                  <a:srgbClr val="0B0B0B"/>
+                </a:solidFill>
+                <a:latin typeface="Arial"/>
+              </a:rPr>
+              <a:t> </a:t>
+            </a:r>
+            <a:r>
+              <a:rPr sz="2460" b="0" i="0">
+                <a:solidFill>
+                  <a:srgbClr val="0B0B0B"/>
+                </a:solidFill>
+                <a:latin typeface="Arial"/>
+              </a:rPr>
+              <a:t>the</a:t>
+            </a:r>
+            <a:r>
+              <a:rPr sz="2460" b="0" i="0">
+                <a:solidFill>
+                  <a:srgbClr val="0B0B0B"/>
+                </a:solidFill>
+                <a:latin typeface="Arial"/>
+              </a:rPr>
+              <a:t> </a:t>
+            </a:r>
+            <a:r>
+              <a:rPr sz="2460" b="0" i="0">
+                <a:solidFill>
+                  <a:srgbClr val="0B0B0B"/>
+                </a:solidFill>
+                <a:latin typeface="Arial"/>
+              </a:rPr>
+              <a:t>verification</a:t>
             </a:r>
           </a:p>
         </p:txBody>
@@ -14615,8 +14345,8 @@
         </p:nvSpPr>
         <p:spPr>
           <a:xfrm>
-            <a:off x="20775739" y="27007157"/>
-            <a:ext cx="6666476" cy="312517"/>
+            <a:off x="20775739" y="26536330"/>
+            <a:ext cx="8620639" cy="312517"/>
           </a:xfrm>
           <a:prstGeom prst="rect">
             <a:avLst/>
@@ -14636,7 +14366,151 @@
                 </a:solidFill>
                 <a:latin typeface="Arial"/>
               </a:rPr>
-              <a:t>Toni) is in review; no biological result is claimed.</a:t>
+              <a:t>interface,</a:t>
+            </a:r>
+            <a:r>
+              <a:rPr sz="2460" b="0" i="0">
+                <a:solidFill>
+                  <a:srgbClr val="0B0B0B"/>
+                </a:solidFill>
+                <a:latin typeface="Arial"/>
+              </a:rPr>
+              <a:t> </a:t>
+            </a:r>
+            <a:r>
+              <a:rPr sz="2460" b="0" i="0">
+                <a:solidFill>
+                  <a:srgbClr val="0B0B0B"/>
+                </a:solidFill>
+                <a:latin typeface="Arial"/>
+              </a:rPr>
+              <a:t>not</a:t>
+            </a:r>
+            <a:r>
+              <a:rPr sz="2460" b="0" i="0">
+                <a:solidFill>
+                  <a:srgbClr val="0B0B0B"/>
+                </a:solidFill>
+                <a:latin typeface="Arial"/>
+              </a:rPr>
+              <a:t> </a:t>
+            </a:r>
+            <a:r>
+              <a:rPr sz="2460" b="0" i="0">
+                <a:solidFill>
+                  <a:srgbClr val="0B0B0B"/>
+                </a:solidFill>
+                <a:latin typeface="Arial"/>
+              </a:rPr>
+              <a:t>ARC</a:t>
+            </a:r>
+            <a:r>
+              <a:rPr sz="2460" b="0" i="0">
+                <a:solidFill>
+                  <a:srgbClr val="0B0B0B"/>
+                </a:solidFill>
+                <a:latin typeface="Arial"/>
+              </a:rPr>
+              <a:t> </a:t>
+            </a:r>
+            <a:r>
+              <a:rPr sz="2460" b="0" i="0">
+                <a:solidFill>
+                  <a:srgbClr val="0B0B0B"/>
+                </a:solidFill>
+                <a:latin typeface="Arial"/>
+              </a:rPr>
+              <a:t>operators.</a:t>
+            </a:r>
+            <a:r>
+              <a:rPr sz="2460" b="0" i="0">
+                <a:solidFill>
+                  <a:srgbClr val="0B0B0B"/>
+                </a:solidFill>
+                <a:latin typeface="Arial"/>
+              </a:rPr>
+              <a:t> </a:t>
+            </a:r>
+            <a:r>
+              <a:rPr sz="2460" b="0" i="0">
+                <a:solidFill>
+                  <a:srgbClr val="0B0B0B"/>
+                </a:solidFill>
+                <a:latin typeface="Arial"/>
+              </a:rPr>
+              <a:t>A</a:t>
+            </a:r>
+            <a:r>
+              <a:rPr sz="2460" b="0" i="0">
+                <a:solidFill>
+                  <a:srgbClr val="0B0B0B"/>
+                </a:solidFill>
+                <a:latin typeface="Arial"/>
+              </a:rPr>
+              <a:t> </a:t>
+            </a:r>
+            <a:r>
+              <a:rPr sz="2460" b="0" i="0">
+                <a:solidFill>
+                  <a:srgbClr val="0B0B0B"/>
+                </a:solidFill>
+                <a:latin typeface="Arial"/>
+              </a:rPr>
+              <a:t>biological</a:t>
+            </a:r>
+            <a:r>
+              <a:rPr sz="2460" b="0" i="0">
+                <a:solidFill>
+                  <a:srgbClr val="0B0B0B"/>
+                </a:solidFill>
+                <a:latin typeface="Arial"/>
+              </a:rPr>
+              <a:t> </a:t>
+            </a:r>
+            <a:r>
+              <a:rPr sz="2460" b="0" i="0">
+                <a:solidFill>
+                  <a:srgbClr val="0B0B0B"/>
+                </a:solidFill>
+                <a:latin typeface="Arial"/>
+              </a:rPr>
+              <a:t>check</a:t>
+            </a:r>
+            <a:r>
+              <a:rPr sz="2460" b="0" i="0">
+                <a:solidFill>
+                  <a:srgbClr val="0B0B0B"/>
+                </a:solidFill>
+                <a:latin typeface="Arial"/>
+              </a:rPr>
+              <a:t> </a:t>
+            </a:r>
+            <a:r>
+              <a:rPr sz="2460" b="0" i="0">
+                <a:solidFill>
+                  <a:srgbClr val="0B0B0B"/>
+                </a:solidFill>
+                <a:latin typeface="Arial"/>
+              </a:rPr>
+              <a:t>needs</a:t>
+            </a:r>
+            <a:r>
+              <a:rPr sz="2460" b="0" i="0">
+                <a:solidFill>
+                  <a:srgbClr val="0B0B0B"/>
+                </a:solidFill>
+                <a:latin typeface="Arial"/>
+              </a:rPr>
+              <a:t> </a:t>
+            </a:r>
+            <a:r>
+              <a:rPr sz="2460" b="0" i="0">
+                <a:solidFill>
+                  <a:srgbClr val="0B0B0B"/>
+                </a:solidFill>
+                <a:latin typeface="Arial"/>
+              </a:rPr>
+              <a:t>toler-</a:t>
             </a:r>
           </a:p>
         </p:txBody>
@@ -14649,8 +14523,8 @@
         </p:nvSpPr>
         <p:spPr>
           <a:xfrm>
-            <a:off x="20775739" y="28550489"/>
-            <a:ext cx="4500559" cy="480795"/>
+            <a:off x="20775739" y="26941205"/>
+            <a:ext cx="8620639" cy="312517"/>
           </a:xfrm>
           <a:prstGeom prst="rect">
             <a:avLst/>
@@ -14664,13 +14538,13 @@
           <a:lstStyle/>
           <a:p>
             <a:r>
-              <a:rPr sz="3790" b="1" i="0">
-                <a:solidFill>
-                  <a:srgbClr val="2A78D6"/>
-                </a:solidFill>
-                <a:latin typeface="Arial"/>
-              </a:rPr>
-              <a:t>Benchmark context</a:t>
+              <a:rPr sz="2460" b="0" i="0">
+                <a:solidFill>
+                  <a:srgbClr val="0B0B0B"/>
+                </a:solidFill>
+                <a:latin typeface="Arial"/>
+              </a:rPr>
+              <a:t>ance, real replicates, held-out conditions and experiments, not</a:t>
             </a:r>
           </a:p>
         </p:txBody>
@@ -14683,8 +14557,8 @@
         </p:nvSpPr>
         <p:spPr>
           <a:xfrm>
-            <a:off x="20775739" y="29635474"/>
-            <a:ext cx="8620751" cy="312774"/>
+            <a:off x="20775739" y="27346095"/>
+            <a:ext cx="8620645" cy="312517"/>
           </a:xfrm>
           <a:prstGeom prst="rect">
             <a:avLst/>
@@ -14704,160 +14578,151 @@
                 </a:solidFill>
                 <a:latin typeface="Arial"/>
               </a:rPr>
-              <a:t>Official</a:t>
-            </a:r>
-            <a:r>
-              <a:rPr sz="2460" b="0" i="0">
-                <a:solidFill>
-                  <a:srgbClr val="0B0B0B"/>
-                </a:solidFill>
-                <a:latin typeface="Arial"/>
-              </a:rPr>
-              <a:t> </a:t>
-            </a:r>
-            <a:r>
-              <a:rPr sz="2460" b="0" i="0">
-                <a:solidFill>
-                  <a:srgbClr val="0B0B0B"/>
-                </a:solidFill>
-                <a:latin typeface="Arial"/>
-              </a:rPr>
-              <a:t>ARC-AGI-2</a:t>
-            </a:r>
-            <a:r>
-              <a:rPr sz="2460" b="0" i="0">
-                <a:solidFill>
-                  <a:srgbClr val="0B0B0B"/>
-                </a:solidFill>
-                <a:latin typeface="Arial"/>
-              </a:rPr>
-              <a:t> </a:t>
-            </a:r>
-            <a:r>
-              <a:rPr sz="2460" b="0" i="0">
-                <a:solidFill>
-                  <a:srgbClr val="0B0B0B"/>
-                </a:solidFill>
-                <a:latin typeface="Arial"/>
-              </a:rPr>
-              <a:t>public</a:t>
-            </a:r>
-            <a:r>
-              <a:rPr sz="2460" b="0" i="0">
-                <a:solidFill>
-                  <a:srgbClr val="0B0B0B"/>
-                </a:solidFill>
-                <a:latin typeface="Arial"/>
-              </a:rPr>
-              <a:t> </a:t>
-            </a:r>
-            <a:r>
-              <a:rPr sz="2460" b="0" i="0">
-                <a:solidFill>
-                  <a:srgbClr val="0B0B0B"/>
-                </a:solidFill>
-                <a:latin typeface="Arial"/>
-              </a:rPr>
-              <a:t>scores:</a:t>
-            </a:r>
-            <a:r>
-              <a:rPr sz="2460" b="0" i="0">
-                <a:solidFill>
-                  <a:srgbClr val="0B0B0B"/>
-                </a:solidFill>
-                <a:latin typeface="Arial"/>
-              </a:rPr>
-              <a:t> </a:t>
-            </a:r>
-            <a:r>
-              <a:rPr sz="2460" b="0" i="0">
-                <a:solidFill>
-                  <a:srgbClr val="0B0B0B"/>
-                </a:solidFill>
-                <a:latin typeface="Arial"/>
-              </a:rPr>
-              <a:t>native</a:t>
-            </a:r>
-            <a:r>
-              <a:rPr sz="2460" b="0" i="0">
-                <a:solidFill>
-                  <a:srgbClr val="0B0B0B"/>
-                </a:solidFill>
-                <a:latin typeface="Arial"/>
-              </a:rPr>
-              <a:t> </a:t>
-            </a:r>
-            <a:r>
-              <a:rPr sz="2460" b="0" i="0">
-                <a:solidFill>
-                  <a:srgbClr val="0B0B0B"/>
-                </a:solidFill>
-                <a:latin typeface="Arial"/>
-              </a:rPr>
-              <a:t>CORA</a:t>
-            </a:r>
-            <a:r>
-              <a:rPr sz="2460" b="1" i="0">
-                <a:solidFill>
-                  <a:srgbClr val="0B0B0B"/>
-                </a:solidFill>
-                <a:latin typeface="Arial"/>
-              </a:rPr>
-              <a:t> </a:t>
-            </a:r>
-            <a:r>
-              <a:rPr sz="2460" b="1" i="0">
-                <a:solidFill>
-                  <a:srgbClr val="0B0B0B"/>
-                </a:solidFill>
-                <a:latin typeface="Arial"/>
-              </a:rPr>
-              <a:t>0.00</a:t>
-            </a:r>
-            <a:r>
-              <a:rPr sz="2460" b="0" i="0">
-                <a:solidFill>
-                  <a:srgbClr val="0B0B0B"/>
-                </a:solidFill>
-                <a:latin typeface="Arial"/>
-              </a:rPr>
-              <a:t>;</a:t>
-            </a:r>
-            <a:r>
-              <a:rPr sz="2460" b="0" i="0">
-                <a:solidFill>
-                  <a:srgbClr val="0B0B0B"/>
-                </a:solidFill>
-                <a:latin typeface="Arial"/>
-              </a:rPr>
-              <a:t> </a:t>
-            </a:r>
-            <a:r>
-              <a:rPr sz="2460" b="0" i="0">
-                <a:solidFill>
-                  <a:srgbClr val="0B0B0B"/>
-                </a:solidFill>
-                <a:latin typeface="Arial"/>
-              </a:rPr>
-              <a:t>a</a:t>
-            </a:r>
-            <a:r>
-              <a:rPr sz="2460" b="0" i="0">
-                <a:solidFill>
-                  <a:srgbClr val="0B0B0B"/>
-                </a:solidFill>
-                <a:latin typeface="Arial"/>
-              </a:rPr>
-              <a:t> </a:t>
-            </a:r>
-            <a:r>
-              <a:rPr sz="2460" b="0" i="0">
-                <a:solidFill>
-                  <a:srgbClr val="0B0B0B"/>
-                </a:solidFill>
-                <a:latin typeface="Arial"/>
-              </a:rPr>
-              <a:t>re-</a:t>
+              <a:t>exact</a:t>
+            </a:r>
+            <a:r>
+              <a:rPr sz="2460" b="0" i="0">
+                <a:solidFill>
+                  <a:srgbClr val="0B0B0B"/>
+                </a:solidFill>
+                <a:latin typeface="Arial"/>
+              </a:rPr>
+              <a:t> </a:t>
+            </a:r>
+            <a:r>
+              <a:rPr sz="2460" b="0" i="0">
+                <a:solidFill>
+                  <a:srgbClr val="0B0B0B"/>
+                </a:solidFill>
+                <a:latin typeface="Arial"/>
+              </a:rPr>
+              <a:t>match.</a:t>
+            </a:r>
+            <a:r>
+              <a:rPr sz="2460" b="0" i="0">
+                <a:solidFill>
+                  <a:srgbClr val="0B0B0B"/>
+                </a:solidFill>
+                <a:latin typeface="Arial"/>
+              </a:rPr>
+              <a:t> </a:t>
+            </a:r>
+            <a:r>
+              <a:rPr sz="2460" b="0" i="0">
+                <a:solidFill>
+                  <a:srgbClr val="0B0B0B"/>
+                </a:solidFill>
+                <a:latin typeface="Arial"/>
+              </a:rPr>
+              <a:t>The</a:t>
+            </a:r>
+            <a:r>
+              <a:rPr sz="2460" b="0" i="0">
+                <a:solidFill>
+                  <a:srgbClr val="0B0B0B"/>
+                </a:solidFill>
+                <a:latin typeface="Arial"/>
+              </a:rPr>
+              <a:t> </a:t>
+            </a:r>
+            <a:r>
+              <a:rPr sz="2460" b="0" i="0">
+                <a:solidFill>
+                  <a:srgbClr val="0B0B0B"/>
+                </a:solidFill>
+                <a:latin typeface="Arial"/>
+              </a:rPr>
+              <a:t>problem</a:t>
+            </a:r>
+            <a:r>
+              <a:rPr sz="2460" b="0" i="0">
+                <a:solidFill>
+                  <a:srgbClr val="0B0B0B"/>
+                </a:solidFill>
+                <a:latin typeface="Arial"/>
+              </a:rPr>
+              <a:t> </a:t>
+            </a:r>
+            <a:r>
+              <a:rPr sz="2460" b="0" i="0">
+                <a:solidFill>
+                  <a:srgbClr val="0B0B0B"/>
+                </a:solidFill>
+                <a:latin typeface="Arial"/>
+              </a:rPr>
+              <a:t>contract</a:t>
+            </a:r>
+            <a:r>
+              <a:rPr sz="2460" b="0" i="0">
+                <a:solidFill>
+                  <a:srgbClr val="0B0B0B"/>
+                </a:solidFill>
+                <a:latin typeface="Arial"/>
+              </a:rPr>
+              <a:t> </a:t>
+            </a:r>
+            <a:r>
+              <a:rPr sz="2460" b="0" i="0">
+                <a:solidFill>
+                  <a:srgbClr val="0B0B0B"/>
+                </a:solidFill>
+                <a:latin typeface="Arial"/>
+              </a:rPr>
+              <a:t>(questions</a:t>
+            </a:r>
+            <a:r>
+              <a:rPr sz="2460" b="0" i="0">
+                <a:solidFill>
+                  <a:srgbClr val="0B0B0B"/>
+                </a:solidFill>
+                <a:latin typeface="Arial"/>
+              </a:rPr>
+              <a:t> </a:t>
+            </a:r>
+            <a:r>
+              <a:rPr sz="2460" b="0" i="0">
+                <a:solidFill>
+                  <a:srgbClr val="0B0B0B"/>
+                </a:solidFill>
+                <a:latin typeface="Arial"/>
+              </a:rPr>
+              <a:t>for</a:t>
+            </a:r>
+            <a:r>
+              <a:rPr sz="2460" b="0" i="0">
+                <a:solidFill>
+                  <a:srgbClr val="0B0B0B"/>
+                </a:solidFill>
+                <a:latin typeface="Arial"/>
+              </a:rPr>
+              <a:t> </a:t>
+            </a:r>
+            <a:r>
+              <a:rPr sz="2460" b="0" i="0">
+                <a:solidFill>
+                  <a:srgbClr val="0B0B0B"/>
+                </a:solidFill>
+                <a:latin typeface="Arial"/>
+              </a:rPr>
+              <a:t>Pierce</a:t>
+            </a:r>
+            <a:r>
+              <a:rPr sz="2460" b="0" i="0">
+                <a:solidFill>
+                  <a:srgbClr val="0B0B0B"/>
+                </a:solidFill>
+                <a:latin typeface="Arial"/>
+              </a:rPr>
+              <a:t> </a:t>
+            </a:r>
+            <a:r>
+              <a:rPr sz="2460" b="0" i="0">
+                <a:solidFill>
+                  <a:srgbClr val="0B0B0B"/>
+                </a:solidFill>
+                <a:latin typeface="Arial"/>
+              </a:rPr>
+              <a:t>and</a:t>
             </a:r>
           </a:p>
         </p:txBody>
@@ -14870,8 +14735,8 @@
         </p:nvSpPr>
         <p:spPr>
           <a:xfrm>
-            <a:off x="20775739" y="30040361"/>
-            <a:ext cx="8620667" cy="312774"/>
+            <a:off x="20775739" y="27750972"/>
+            <a:ext cx="6666476" cy="312517"/>
           </a:xfrm>
           <a:prstGeom prst="rect">
             <a:avLst/>
@@ -14891,25 +14756,7 @@
                 </a:solidFill>
                 <a:latin typeface="Arial"/>
               </a:rPr>
-              <a:t>production of the published NVARC Qwen3-4B pipeline</a:t>
-            </a:r>
-            <a:r>
-              <a:rPr sz="2460" b="1" i="0">
-                <a:solidFill>
-                  <a:srgbClr val="0B0B0B"/>
-                </a:solidFill>
-                <a:latin typeface="Arial"/>
-              </a:rPr>
-              <a:t> 27.64</a:t>
-            </a:r>
-            <a:r>
-              <a:rPr sz="2460" b="0" i="0">
-                <a:solidFill>
-                  <a:srgbClr val="0B0B0B"/>
-                </a:solidFill>
-                <a:latin typeface="Arial"/>
-              </a:rPr>
-              <a:t>,</a:t>
+              <a:t>Toni) is in review; no biological result is claimed.</a:t>
             </a:r>
           </a:p>
         </p:txBody>
@@ -14922,8 +14769,8 @@
         </p:nvSpPr>
         <p:spPr>
           <a:xfrm>
-            <a:off x="20775738" y="30445239"/>
-            <a:ext cx="8620659" cy="312774"/>
+            <a:off x="20775739" y="29294301"/>
+            <a:ext cx="4500559" cy="480795"/>
           </a:xfrm>
           <a:prstGeom prst="rect">
             <a:avLst/>
@@ -14937,184 +14784,13 @@
           <a:lstStyle/>
           <a:p>
             <a:r>
-              <a:rPr sz="2460" b="0" i="0">
-                <a:solidFill>
-                  <a:srgbClr val="0B0B0B"/>
-                </a:solidFill>
-                <a:latin typeface="Arial"/>
-              </a:rPr>
-              <a:t>which</a:t>
-            </a:r>
-            <a:r>
-              <a:rPr sz="2460" b="0" i="0">
-                <a:solidFill>
-                  <a:srgbClr val="0B0B0B"/>
-                </a:solidFill>
-                <a:latin typeface="Arial"/>
-              </a:rPr>
-              <a:t> </a:t>
-            </a:r>
-            <a:r>
-              <a:rPr sz="2460" b="0" i="0">
-                <a:solidFill>
-                  <a:srgbClr val="0B0B0B"/>
-                </a:solidFill>
-                <a:latin typeface="Arial"/>
-              </a:rPr>
-              <a:t>is</a:t>
-            </a:r>
-            <a:r>
-              <a:rPr sz="2460" b="1" i="0">
-                <a:solidFill>
-                  <a:srgbClr val="0B0B0B"/>
-                </a:solidFill>
-                <a:latin typeface="Arial"/>
-              </a:rPr>
-              <a:t> </a:t>
-            </a:r>
-            <a:r>
-              <a:rPr sz="2460" b="1" i="0">
-                <a:solidFill>
-                  <a:srgbClr val="0B0B0B"/>
-                </a:solidFill>
-                <a:latin typeface="Arial"/>
-              </a:rPr>
-              <a:t>not</a:t>
-            </a:r>
-            <a:r>
-              <a:rPr sz="2460" b="1" i="0">
-                <a:solidFill>
-                  <a:srgbClr val="0B0B0B"/>
-                </a:solidFill>
-                <a:latin typeface="Arial"/>
-              </a:rPr>
-              <a:t> </a:t>
-            </a:r>
-            <a:r>
-              <a:rPr sz="2460" b="1" i="0">
-                <a:solidFill>
-                  <a:srgbClr val="0B0B0B"/>
-                </a:solidFill>
-                <a:latin typeface="Arial"/>
-              </a:rPr>
-              <a:t>CORA</a:t>
-            </a:r>
-            <a:r>
-              <a:rPr sz="2460" b="0" i="0">
-                <a:solidFill>
-                  <a:srgbClr val="0B0B0B"/>
-                </a:solidFill>
-                <a:latin typeface="Arial"/>
-              </a:rPr>
-              <a:t>.</a:t>
-            </a:r>
-            <a:r>
-              <a:rPr sz="2460" b="0" i="0">
-                <a:solidFill>
-                  <a:srgbClr val="0B0B0B"/>
-                </a:solidFill>
-                <a:latin typeface="Arial"/>
-              </a:rPr>
-              <a:t> </a:t>
-            </a:r>
-            <a:r>
-              <a:rPr sz="2460" b="0" i="0">
-                <a:solidFill>
-                  <a:srgbClr val="0B0B0B"/>
-                </a:solidFill>
-                <a:latin typeface="Arial"/>
-              </a:rPr>
-              <a:t>The</a:t>
-            </a:r>
-            <a:r>
-              <a:rPr sz="2460" b="0" i="0">
-                <a:solidFill>
-                  <a:srgbClr val="0B0B0B"/>
-                </a:solidFill>
-                <a:latin typeface="Arial"/>
-              </a:rPr>
-              <a:t> </a:t>
-            </a:r>
-            <a:r>
-              <a:rPr sz="2460" b="0" i="0">
-                <a:solidFill>
-                  <a:srgbClr val="0B0B0B"/>
-                </a:solidFill>
-                <a:latin typeface="Arial"/>
-              </a:rPr>
-              <a:t>CORA-FHR</a:t>
-            </a:r>
-            <a:r>
-              <a:rPr sz="2460" b="0" i="0">
-                <a:solidFill>
-                  <a:srgbClr val="0B0B0B"/>
-                </a:solidFill>
-                <a:latin typeface="Arial"/>
-              </a:rPr>
-              <a:t> </a:t>
-            </a:r>
-            <a:r>
-              <a:rPr sz="2460" b="0" i="0">
-                <a:solidFill>
-                  <a:srgbClr val="0B0B0B"/>
-                </a:solidFill>
-                <a:latin typeface="Arial"/>
-              </a:rPr>
-              <a:t>research</a:t>
-            </a:r>
-            <a:r>
-              <a:rPr sz="2460" b="0" i="0">
-                <a:solidFill>
-                  <a:srgbClr val="0B0B0B"/>
-                </a:solidFill>
-                <a:latin typeface="Arial"/>
-              </a:rPr>
-              <a:t> </a:t>
-            </a:r>
-            <a:r>
-              <a:rPr sz="2460" b="0" i="0">
-                <a:solidFill>
-                  <a:srgbClr val="0B0B0B"/>
-                </a:solidFill>
-                <a:latin typeface="Arial"/>
-              </a:rPr>
-              <a:t>entry</a:t>
-            </a:r>
-            <a:r>
-              <a:rPr sz="2460" b="0" i="0">
-                <a:solidFill>
-                  <a:srgbClr val="0B0B0B"/>
-                </a:solidFill>
-                <a:latin typeface="Arial"/>
-              </a:rPr>
-              <a:t> </a:t>
-            </a:r>
-            <a:r>
-              <a:rPr sz="2460" b="0" i="0">
-                <a:solidFill>
-                  <a:srgbClr val="0B0B0B"/>
-                </a:solidFill>
-                <a:latin typeface="Arial"/>
-              </a:rPr>
-              <a:t>(18</a:t>
-            </a:r>
-            <a:r>
-              <a:rPr sz="2460" b="0" i="0">
-                <a:solidFill>
-                  <a:srgbClr val="0B0B0B"/>
-                </a:solidFill>
-                <a:latin typeface="Arial"/>
-              </a:rPr>
-              <a:t> </a:t>
-            </a:r>
-            <a:r>
-              <a:rPr sz="2460" b="0" i="0">
-                <a:solidFill>
-                  <a:srgbClr val="0B0B0B"/>
-                </a:solidFill>
-                <a:latin typeface="Arial"/>
-              </a:rPr>
-              <a:t>Oc-</a:t>
+              <a:rPr sz="3790" b="1" i="0">
+                <a:solidFill>
+                  <a:srgbClr val="2A78D6"/>
+                </a:solidFill>
+                <a:latin typeface="Arial"/>
+              </a:rPr>
+              <a:t>Benchmark context</a:t>
             </a:r>
           </a:p>
         </p:txBody>
@@ -15127,8 +14803,8 @@
         </p:nvSpPr>
         <p:spPr>
           <a:xfrm>
-            <a:off x="20775738" y="30850126"/>
-            <a:ext cx="8620759" cy="312774"/>
+            <a:off x="20775739" y="30379299"/>
+            <a:ext cx="8620751" cy="312774"/>
           </a:xfrm>
           <a:prstGeom prst="rect">
             <a:avLst/>
@@ -15148,25 +14824,97 @@
                 </a:solidFill>
                 <a:latin typeface="Arial"/>
               </a:rPr>
-              <a:t>tober)</a:t>
-            </a:r>
-            <a:r>
-              <a:rPr sz="2460" b="0" i="0">
-                <a:solidFill>
-                  <a:srgbClr val="0B0B0B"/>
-                </a:solidFill>
-                <a:latin typeface="Arial"/>
-              </a:rPr>
-              <a:t> </a:t>
-            </a:r>
-            <a:r>
-              <a:rPr sz="2460" b="0" i="0">
-                <a:solidFill>
-                  <a:srgbClr val="0B0B0B"/>
-                </a:solidFill>
-                <a:latin typeface="Arial"/>
-              </a:rPr>
-              <a:t>scored</a:t>
+              <a:t>Official</a:t>
+            </a:r>
+            <a:r>
+              <a:rPr sz="2460" b="0" i="0">
+                <a:solidFill>
+                  <a:srgbClr val="0B0B0B"/>
+                </a:solidFill>
+                <a:latin typeface="Arial"/>
+              </a:rPr>
+              <a:t> </a:t>
+            </a:r>
+            <a:r>
+              <a:rPr sz="2460" b="0" i="0">
+                <a:solidFill>
+                  <a:srgbClr val="0B0B0B"/>
+                </a:solidFill>
+                <a:latin typeface="Arial"/>
+              </a:rPr>
+              <a:t>ARC-AGI-2</a:t>
+            </a:r>
+            <a:r>
+              <a:rPr sz="2460" b="0" i="0">
+                <a:solidFill>
+                  <a:srgbClr val="0B0B0B"/>
+                </a:solidFill>
+                <a:latin typeface="Arial"/>
+              </a:rPr>
+              <a:t> </a:t>
+            </a:r>
+            <a:r>
+              <a:rPr sz="2460" b="0" i="0">
+                <a:solidFill>
+                  <a:srgbClr val="0B0B0B"/>
+                </a:solidFill>
+                <a:latin typeface="Arial"/>
+              </a:rPr>
+              <a:t>public</a:t>
+            </a:r>
+            <a:r>
+              <a:rPr sz="2460" b="0" i="0">
+                <a:solidFill>
+                  <a:srgbClr val="0B0B0B"/>
+                </a:solidFill>
+                <a:latin typeface="Arial"/>
+              </a:rPr>
+              <a:t> </a:t>
+            </a:r>
+            <a:r>
+              <a:rPr sz="2460" b="0" i="0">
+                <a:solidFill>
+                  <a:srgbClr val="0B0B0B"/>
+                </a:solidFill>
+                <a:latin typeface="Arial"/>
+              </a:rPr>
+              <a:t>scores:</a:t>
+            </a:r>
+            <a:r>
+              <a:rPr sz="2460" b="0" i="0">
+                <a:solidFill>
+                  <a:srgbClr val="0B0B0B"/>
+                </a:solidFill>
+                <a:latin typeface="Arial"/>
+              </a:rPr>
+              <a:t> </a:t>
+            </a:r>
+            <a:r>
+              <a:rPr sz="2460" b="0" i="0">
+                <a:solidFill>
+                  <a:srgbClr val="0B0B0B"/>
+                </a:solidFill>
+                <a:latin typeface="Arial"/>
+              </a:rPr>
+              <a:t>native</a:t>
+            </a:r>
+            <a:r>
+              <a:rPr sz="2460" b="0" i="0">
+                <a:solidFill>
+                  <a:srgbClr val="0B0B0B"/>
+                </a:solidFill>
+                <a:latin typeface="Arial"/>
+              </a:rPr>
+              <a:t> </a:t>
+            </a:r>
+            <a:r>
+              <a:rPr sz="2460" b="0" i="0">
+                <a:solidFill>
+                  <a:srgbClr val="0B0B0B"/>
+                </a:solidFill>
+                <a:latin typeface="Arial"/>
+              </a:rPr>
+              <a:t>CORA</a:t>
             </a:r>
             <a:r>
               <a:rPr sz="2460" b="1" i="0">
@@ -15193,133 +14941,43 @@
                 </a:solidFill>
                 <a:latin typeface="Arial"/>
               </a:rPr>
-              <a:t>,</a:t>
-            </a:r>
-            <a:r>
-              <a:rPr sz="2460" b="0" i="0">
-                <a:solidFill>
-                  <a:srgbClr val="0B0B0B"/>
-                </a:solidFill>
-                <a:latin typeface="Arial"/>
-              </a:rPr>
-              <a:t> </a:t>
-            </a:r>
-            <a:r>
-              <a:rPr sz="2460" b="0" i="0">
-                <a:solidFill>
-                  <a:srgbClr val="0B0B0B"/>
-                </a:solidFill>
-                <a:latin typeface="Arial"/>
-              </a:rPr>
-              <a:t>as</a:t>
-            </a:r>
-            <a:r>
-              <a:rPr sz="2460" b="0" i="0">
-                <a:solidFill>
-                  <a:srgbClr val="0B0B0B"/>
-                </a:solidFill>
-                <a:latin typeface="Arial"/>
-              </a:rPr>
-              <a:t> </a:t>
-            </a:r>
-            <a:r>
-              <a:rPr sz="2460" b="0" i="0">
-                <a:solidFill>
-                  <a:srgbClr val="0B0B0B"/>
-                </a:solidFill>
-                <a:latin typeface="Arial"/>
-              </a:rPr>
-              <a:t>its</a:t>
-            </a:r>
-            <a:r>
-              <a:rPr sz="2460" b="0" i="0">
-                <a:solidFill>
-                  <a:srgbClr val="0B0B0B"/>
-                </a:solidFill>
-                <a:latin typeface="Arial"/>
-              </a:rPr>
-              <a:t> </a:t>
-            </a:r>
-            <a:r>
-              <a:rPr sz="2460" b="0" i="0">
-                <a:solidFill>
-                  <a:srgbClr val="0B0B0B"/>
-                </a:solidFill>
-                <a:latin typeface="Arial"/>
-              </a:rPr>
-              <a:t>local</a:t>
-            </a:r>
-            <a:r>
-              <a:rPr sz="2460" b="0" i="0">
-                <a:solidFill>
-                  <a:srgbClr val="0B0B0B"/>
-                </a:solidFill>
-                <a:latin typeface="Arial"/>
-              </a:rPr>
-              <a:t> </a:t>
-            </a:r>
-            <a:r>
-              <a:rPr sz="2460" b="0" i="0">
-                <a:solidFill>
-                  <a:srgbClr val="0B0B0B"/>
-                </a:solidFill>
-                <a:latin typeface="Arial"/>
-              </a:rPr>
-              <a:t>rehearsal</a:t>
-            </a:r>
-            <a:r>
-              <a:rPr sz="2460" b="0" i="0">
-                <a:solidFill>
-                  <a:srgbClr val="0B0B0B"/>
-                </a:solidFill>
-                <a:latin typeface="Arial"/>
-              </a:rPr>
-              <a:t> </a:t>
-            </a:r>
-            <a:r>
-              <a:rPr sz="2460" b="0" i="0">
-                <a:solidFill>
-                  <a:srgbClr val="0B0B0B"/>
-                </a:solidFill>
-                <a:latin typeface="Arial"/>
-              </a:rPr>
-              <a:t>predicted</a:t>
-            </a:r>
-            <a:r>
-              <a:rPr sz="2460" b="0" i="0">
-                <a:solidFill>
-                  <a:srgbClr val="0B0B0B"/>
-                </a:solidFill>
-                <a:latin typeface="Arial"/>
-              </a:rPr>
-              <a:t> </a:t>
-            </a:r>
-            <a:r>
-              <a:rPr sz="2460" b="0" i="0">
-                <a:solidFill>
-                  <a:srgbClr val="0B0B0B"/>
-                </a:solidFill>
-                <a:latin typeface="Arial"/>
-              </a:rPr>
-              <a:t>(no</a:t>
-            </a:r>
-            <a:r>
-              <a:rPr sz="2460" b="0" i="0">
-                <a:solidFill>
-                  <a:srgbClr val="0B0B0B"/>
-                </a:solidFill>
-                <a:latin typeface="Arial"/>
-              </a:rPr>
-              <a:t> </a:t>
-            </a:r>
-            <a:r>
-              <a:rPr sz="2460" b="0" i="0">
-                <a:solidFill>
-                  <a:srgbClr val="0B0B0B"/>
-                </a:solidFill>
-                <a:latin typeface="Arial"/>
-              </a:rPr>
-              <a:t>new</a:t>
+              <a:t>;</a:t>
+            </a:r>
+            <a:r>
+              <a:rPr sz="2460" b="0" i="0">
+                <a:solidFill>
+                  <a:srgbClr val="0B0B0B"/>
+                </a:solidFill>
+                <a:latin typeface="Arial"/>
+              </a:rPr>
+              <a:t> </a:t>
+            </a:r>
+            <a:r>
+              <a:rPr sz="2460" b="0" i="0">
+                <a:solidFill>
+                  <a:srgbClr val="0B0B0B"/>
+                </a:solidFill>
+                <a:latin typeface="Arial"/>
+              </a:rPr>
+              <a:t>a</a:t>
+            </a:r>
+            <a:r>
+              <a:rPr sz="2460" b="0" i="0">
+                <a:solidFill>
+                  <a:srgbClr val="0B0B0B"/>
+                </a:solidFill>
+                <a:latin typeface="Arial"/>
+              </a:rPr>
+              <a:t> </a:t>
+            </a:r>
+            <a:r>
+              <a:rPr sz="2460" b="0" i="0">
+                <a:solidFill>
+                  <a:srgbClr val="0B0B0B"/>
+                </a:solidFill>
+                <a:latin typeface="Arial"/>
+              </a:rPr>
+              <a:t>re-</a:t>
             </a:r>
           </a:p>
         </p:txBody>
@@ -15332,8 +14990,8 @@
         </p:nvSpPr>
         <p:spPr>
           <a:xfrm>
-            <a:off x="20775739" y="31255003"/>
-            <a:ext cx="8620648" cy="312517"/>
+            <a:off x="20775739" y="30784176"/>
+            <a:ext cx="8620667" cy="312774"/>
           </a:xfrm>
           <a:prstGeom prst="rect">
             <a:avLst/>
@@ -15353,169 +15011,25 @@
                 </a:solidFill>
                 <a:latin typeface="Arial"/>
               </a:rPr>
-              <a:t>answer</a:t>
-            </a:r>
-            <a:r>
-              <a:rPr sz="2460" b="0" i="0">
-                <a:solidFill>
-                  <a:srgbClr val="0B0B0B"/>
-                </a:solidFill>
-                <a:latin typeface="Arial"/>
-              </a:rPr>
-              <a:t> </a:t>
-            </a:r>
-            <a:r>
-              <a:rPr sz="2460" b="0" i="0">
-                <a:solidFill>
-                  <a:srgbClr val="0B0B0B"/>
-                </a:solidFill>
-                <a:latin typeface="Arial"/>
-              </a:rPr>
-              <a:t>committed).</a:t>
-            </a:r>
-            <a:r>
-              <a:rPr sz="2460" b="0" i="0">
-                <a:solidFill>
-                  <a:srgbClr val="0B0B0B"/>
-                </a:solidFill>
-                <a:latin typeface="Arial"/>
-              </a:rPr>
-              <a:t> </a:t>
-            </a:r>
-            <a:r>
-              <a:rPr sz="2460" b="0" i="0">
-                <a:solidFill>
-                  <a:srgbClr val="0B0B0B"/>
-                </a:solidFill>
-                <a:latin typeface="Arial"/>
-              </a:rPr>
-              <a:t>The</a:t>
-            </a:r>
-            <a:r>
-              <a:rPr sz="2460" b="0" i="0">
-                <a:solidFill>
-                  <a:srgbClr val="0B0B0B"/>
-                </a:solidFill>
-                <a:latin typeface="Arial"/>
-              </a:rPr>
-              <a:t> </a:t>
-            </a:r>
-            <a:r>
-              <a:rPr sz="2460" b="0" i="0">
-                <a:solidFill>
-                  <a:srgbClr val="0B0B0B"/>
-                </a:solidFill>
-                <a:latin typeface="Arial"/>
-              </a:rPr>
-              <a:t>guarded</a:t>
-            </a:r>
-            <a:r>
-              <a:rPr sz="2460" b="0" i="0">
-                <a:solidFill>
-                  <a:srgbClr val="0B0B0B"/>
-                </a:solidFill>
-                <a:latin typeface="Arial"/>
-              </a:rPr>
-              <a:t> </a:t>
-            </a:r>
-            <a:r>
-              <a:rPr sz="2460" b="0" i="0">
-                <a:solidFill>
-                  <a:srgbClr val="0B0B0B"/>
-                </a:solidFill>
-                <a:latin typeface="Arial"/>
-              </a:rPr>
-              <a:t>rule</a:t>
-            </a:r>
-            <a:r>
-              <a:rPr sz="2460" b="0" i="0">
-                <a:solidFill>
-                  <a:srgbClr val="0B0B0B"/>
-                </a:solidFill>
-                <a:latin typeface="Arial"/>
-              </a:rPr>
-              <a:t> </a:t>
-            </a:r>
-            <a:r>
-              <a:rPr sz="2460" b="0" i="0">
-                <a:solidFill>
-                  <a:srgbClr val="0B0B0B"/>
-                </a:solidFill>
-                <a:latin typeface="Arial"/>
-              </a:rPr>
-              <a:t>came</a:t>
-            </a:r>
-            <a:r>
-              <a:rPr sz="2460" b="0" i="0">
-                <a:solidFill>
-                  <a:srgbClr val="0B0B0B"/>
-                </a:solidFill>
-                <a:latin typeface="Arial"/>
-              </a:rPr>
-              <a:t> </a:t>
-            </a:r>
-            <a:r>
-              <a:rPr sz="2460" b="0" i="0">
-                <a:solidFill>
-                  <a:srgbClr val="0B0B0B"/>
-                </a:solidFill>
-                <a:latin typeface="Arial"/>
-              </a:rPr>
-              <a:t>later</a:t>
-            </a:r>
-            <a:r>
-              <a:rPr sz="2460" b="0" i="0">
-                <a:solidFill>
-                  <a:srgbClr val="0B0B0B"/>
-                </a:solidFill>
-                <a:latin typeface="Arial"/>
-              </a:rPr>
-              <a:t> </a:t>
-            </a:r>
-            <a:r>
-              <a:rPr sz="2460" b="0" i="0">
-                <a:solidFill>
-                  <a:srgbClr val="0B0B0B"/>
-                </a:solidFill>
-                <a:latin typeface="Arial"/>
-              </a:rPr>
-              <a:t>and</a:t>
-            </a:r>
-            <a:r>
-              <a:rPr sz="2460" b="0" i="0">
-                <a:solidFill>
-                  <a:srgbClr val="0B0B0B"/>
-                </a:solidFill>
-                <a:latin typeface="Arial"/>
-              </a:rPr>
-              <a:t> </a:t>
-            </a:r>
-            <a:r>
-              <a:rPr sz="2460" b="0" i="0">
-                <a:solidFill>
-                  <a:srgbClr val="0B0B0B"/>
-                </a:solidFill>
-                <a:latin typeface="Arial"/>
-              </a:rPr>
-              <a:t>is</a:t>
-            </a:r>
-            <a:r>
-              <a:rPr sz="2460" b="0" i="0">
-                <a:solidFill>
-                  <a:srgbClr val="0B0B0B"/>
-                </a:solidFill>
-                <a:latin typeface="Arial"/>
-              </a:rPr>
-              <a:t> </a:t>
-            </a:r>
-            <a:r>
-              <a:rPr sz="2460" b="0" i="0">
-                <a:solidFill>
-                  <a:srgbClr val="0B0B0B"/>
-                </a:solidFill>
-                <a:latin typeface="Arial"/>
-              </a:rPr>
-              <a:t>not</a:t>
+              <a:t>production of the published NVARC Qwen3-4B pipeline</a:t>
+            </a:r>
+            <a:r>
+              <a:rPr sz="2460" b="1" i="0">
+                <a:solidFill>
+                  <a:srgbClr val="0B0B0B"/>
+                </a:solidFill>
+                <a:latin typeface="Arial"/>
+              </a:rPr>
+              <a:t> 27.64</a:t>
+            </a:r>
+            <a:r>
+              <a:rPr sz="2460" b="0" i="0">
+                <a:solidFill>
+                  <a:srgbClr val="0B0B0B"/>
+                </a:solidFill>
+                <a:latin typeface="Arial"/>
+              </a:rPr>
+              <a:t>,</a:t>
             </a:r>
           </a:p>
         </p:txBody>
@@ -15528,8 +15042,8 @@
         </p:nvSpPr>
         <p:spPr>
           <a:xfrm>
-            <a:off x="20775739" y="31659890"/>
-            <a:ext cx="1279306" cy="312517"/>
+            <a:off x="20775738" y="31189063"/>
+            <a:ext cx="8620659" cy="312774"/>
           </a:xfrm>
           <a:prstGeom prst="rect">
             <a:avLst/>
@@ -15549,7 +15063,178 @@
                 </a:solidFill>
                 <a:latin typeface="Arial"/>
               </a:rPr>
-              <a:t>part of it.</a:t>
+              <a:t>which</a:t>
+            </a:r>
+            <a:r>
+              <a:rPr sz="2460" b="0" i="0">
+                <a:solidFill>
+                  <a:srgbClr val="0B0B0B"/>
+                </a:solidFill>
+                <a:latin typeface="Arial"/>
+              </a:rPr>
+              <a:t> </a:t>
+            </a:r>
+            <a:r>
+              <a:rPr sz="2460" b="0" i="0">
+                <a:solidFill>
+                  <a:srgbClr val="0B0B0B"/>
+                </a:solidFill>
+                <a:latin typeface="Arial"/>
+              </a:rPr>
+              <a:t>is</a:t>
+            </a:r>
+            <a:r>
+              <a:rPr sz="2460" b="1" i="0">
+                <a:solidFill>
+                  <a:srgbClr val="0B0B0B"/>
+                </a:solidFill>
+                <a:latin typeface="Arial"/>
+              </a:rPr>
+              <a:t> </a:t>
+            </a:r>
+            <a:r>
+              <a:rPr sz="2460" b="1" i="0">
+                <a:solidFill>
+                  <a:srgbClr val="0B0B0B"/>
+                </a:solidFill>
+                <a:latin typeface="Arial"/>
+              </a:rPr>
+              <a:t>not</a:t>
+            </a:r>
+            <a:r>
+              <a:rPr sz="2460" b="1" i="0">
+                <a:solidFill>
+                  <a:srgbClr val="0B0B0B"/>
+                </a:solidFill>
+                <a:latin typeface="Arial"/>
+              </a:rPr>
+              <a:t> </a:t>
+            </a:r>
+            <a:r>
+              <a:rPr sz="2460" b="1" i="0">
+                <a:solidFill>
+                  <a:srgbClr val="0B0B0B"/>
+                </a:solidFill>
+                <a:latin typeface="Arial"/>
+              </a:rPr>
+              <a:t>CORA</a:t>
+            </a:r>
+            <a:r>
+              <a:rPr sz="2460" b="0" i="0">
+                <a:solidFill>
+                  <a:srgbClr val="0B0B0B"/>
+                </a:solidFill>
+                <a:latin typeface="Arial"/>
+              </a:rPr>
+              <a:t>.</a:t>
+            </a:r>
+            <a:r>
+              <a:rPr sz="2460" b="0" i="0">
+                <a:solidFill>
+                  <a:srgbClr val="0B0B0B"/>
+                </a:solidFill>
+                <a:latin typeface="Arial"/>
+              </a:rPr>
+              <a:t> </a:t>
+            </a:r>
+            <a:r>
+              <a:rPr sz="2460" b="0" i="0">
+                <a:solidFill>
+                  <a:srgbClr val="0B0B0B"/>
+                </a:solidFill>
+                <a:latin typeface="Arial"/>
+              </a:rPr>
+              <a:t>The</a:t>
+            </a:r>
+            <a:r>
+              <a:rPr sz="2460" b="0" i="0">
+                <a:solidFill>
+                  <a:srgbClr val="0B0B0B"/>
+                </a:solidFill>
+                <a:latin typeface="Arial"/>
+              </a:rPr>
+              <a:t> </a:t>
+            </a:r>
+            <a:r>
+              <a:rPr sz="2460" b="0" i="0">
+                <a:solidFill>
+                  <a:srgbClr val="0B0B0B"/>
+                </a:solidFill>
+                <a:latin typeface="Arial"/>
+              </a:rPr>
+              <a:t>CORA-FHR</a:t>
+            </a:r>
+            <a:r>
+              <a:rPr sz="2460" b="0" i="0">
+                <a:solidFill>
+                  <a:srgbClr val="0B0B0B"/>
+                </a:solidFill>
+                <a:latin typeface="Arial"/>
+              </a:rPr>
+              <a:t> </a:t>
+            </a:r>
+            <a:r>
+              <a:rPr sz="2460" b="0" i="0">
+                <a:solidFill>
+                  <a:srgbClr val="0B0B0B"/>
+                </a:solidFill>
+                <a:latin typeface="Arial"/>
+              </a:rPr>
+              <a:t>research</a:t>
+            </a:r>
+            <a:r>
+              <a:rPr sz="2460" b="0" i="0">
+                <a:solidFill>
+                  <a:srgbClr val="0B0B0B"/>
+                </a:solidFill>
+                <a:latin typeface="Arial"/>
+              </a:rPr>
+              <a:t> </a:t>
+            </a:r>
+            <a:r>
+              <a:rPr sz="2460" b="0" i="0">
+                <a:solidFill>
+                  <a:srgbClr val="0B0B0B"/>
+                </a:solidFill>
+                <a:latin typeface="Arial"/>
+              </a:rPr>
+              <a:t>entry</a:t>
+            </a:r>
+            <a:r>
+              <a:rPr sz="2460" b="0" i="0">
+                <a:solidFill>
+                  <a:srgbClr val="0B0B0B"/>
+                </a:solidFill>
+                <a:latin typeface="Arial"/>
+              </a:rPr>
+              <a:t> </a:t>
+            </a:r>
+            <a:r>
+              <a:rPr sz="2460" b="0" i="0">
+                <a:solidFill>
+                  <a:srgbClr val="0B0B0B"/>
+                </a:solidFill>
+                <a:latin typeface="Arial"/>
+              </a:rPr>
+              <a:t>(18</a:t>
+            </a:r>
+            <a:r>
+              <a:rPr sz="2460" b="0" i="0">
+                <a:solidFill>
+                  <a:srgbClr val="0B0B0B"/>
+                </a:solidFill>
+                <a:latin typeface="Arial"/>
+              </a:rPr>
+              <a:t> </a:t>
+            </a:r>
+            <a:r>
+              <a:rPr sz="2460" b="0" i="0">
+                <a:solidFill>
+                  <a:srgbClr val="0B0B0B"/>
+                </a:solidFill>
+                <a:latin typeface="Arial"/>
+              </a:rPr>
+              <a:t>Oc-</a:t>
             </a:r>
           </a:p>
         </p:txBody>
@@ -15562,8 +15247,8 @@
         </p:nvSpPr>
         <p:spPr>
           <a:xfrm>
-            <a:off x="20775739" y="33209814"/>
-            <a:ext cx="6855984" cy="480795"/>
+            <a:off x="20775738" y="31593941"/>
+            <a:ext cx="8620759" cy="312774"/>
           </a:xfrm>
           <a:prstGeom prst="rect">
             <a:avLst/>
@@ -15577,13 +15262,184 @@
           <a:lstStyle/>
           <a:p>
             <a:r>
-              <a:rPr sz="3790" b="1" i="0">
-                <a:solidFill>
-                  <a:srgbClr val="2A78D6"/>
-                </a:solidFill>
-                <a:latin typeface="Arial"/>
-              </a:rPr>
-              <a:t>The question I want to pursue</a:t>
+              <a:rPr sz="2460" b="0" i="0">
+                <a:solidFill>
+                  <a:srgbClr val="0B0B0B"/>
+                </a:solidFill>
+                <a:latin typeface="Arial"/>
+              </a:rPr>
+              <a:t>tober)</a:t>
+            </a:r>
+            <a:r>
+              <a:rPr sz="2460" b="0" i="0">
+                <a:solidFill>
+                  <a:srgbClr val="0B0B0B"/>
+                </a:solidFill>
+                <a:latin typeface="Arial"/>
+              </a:rPr>
+              <a:t> </a:t>
+            </a:r>
+            <a:r>
+              <a:rPr sz="2460" b="0" i="0">
+                <a:solidFill>
+                  <a:srgbClr val="0B0B0B"/>
+                </a:solidFill>
+                <a:latin typeface="Arial"/>
+              </a:rPr>
+              <a:t>scored</a:t>
+            </a:r>
+            <a:r>
+              <a:rPr sz="2460" b="1" i="0">
+                <a:solidFill>
+                  <a:srgbClr val="0B0B0B"/>
+                </a:solidFill>
+                <a:latin typeface="Arial"/>
+              </a:rPr>
+              <a:t> </a:t>
+            </a:r>
+            <a:r>
+              <a:rPr sz="2460" b="1" i="0">
+                <a:solidFill>
+                  <a:srgbClr val="0B0B0B"/>
+                </a:solidFill>
+                <a:latin typeface="Arial"/>
+              </a:rPr>
+              <a:t>0.00</a:t>
+            </a:r>
+            <a:r>
+              <a:rPr sz="2460" b="0" i="0">
+                <a:solidFill>
+                  <a:srgbClr val="0B0B0B"/>
+                </a:solidFill>
+                <a:latin typeface="Arial"/>
+              </a:rPr>
+              <a:t>,</a:t>
+            </a:r>
+            <a:r>
+              <a:rPr sz="2460" b="0" i="0">
+                <a:solidFill>
+                  <a:srgbClr val="0B0B0B"/>
+                </a:solidFill>
+                <a:latin typeface="Arial"/>
+              </a:rPr>
+              <a:t> </a:t>
+            </a:r>
+            <a:r>
+              <a:rPr sz="2460" b="0" i="0">
+                <a:solidFill>
+                  <a:srgbClr val="0B0B0B"/>
+                </a:solidFill>
+                <a:latin typeface="Arial"/>
+              </a:rPr>
+              <a:t>as</a:t>
+            </a:r>
+            <a:r>
+              <a:rPr sz="2460" b="0" i="0">
+                <a:solidFill>
+                  <a:srgbClr val="0B0B0B"/>
+                </a:solidFill>
+                <a:latin typeface="Arial"/>
+              </a:rPr>
+              <a:t> </a:t>
+            </a:r>
+            <a:r>
+              <a:rPr sz="2460" b="0" i="0">
+                <a:solidFill>
+                  <a:srgbClr val="0B0B0B"/>
+                </a:solidFill>
+                <a:latin typeface="Arial"/>
+              </a:rPr>
+              <a:t>its</a:t>
+            </a:r>
+            <a:r>
+              <a:rPr sz="2460" b="0" i="0">
+                <a:solidFill>
+                  <a:srgbClr val="0B0B0B"/>
+                </a:solidFill>
+                <a:latin typeface="Arial"/>
+              </a:rPr>
+              <a:t> </a:t>
+            </a:r>
+            <a:r>
+              <a:rPr sz="2460" b="0" i="0">
+                <a:solidFill>
+                  <a:srgbClr val="0B0B0B"/>
+                </a:solidFill>
+                <a:latin typeface="Arial"/>
+              </a:rPr>
+              <a:t>local</a:t>
+            </a:r>
+            <a:r>
+              <a:rPr sz="2460" b="0" i="0">
+                <a:solidFill>
+                  <a:srgbClr val="0B0B0B"/>
+                </a:solidFill>
+                <a:latin typeface="Arial"/>
+              </a:rPr>
+              <a:t> </a:t>
+            </a:r>
+            <a:r>
+              <a:rPr sz="2460" b="0" i="0">
+                <a:solidFill>
+                  <a:srgbClr val="0B0B0B"/>
+                </a:solidFill>
+                <a:latin typeface="Arial"/>
+              </a:rPr>
+              <a:t>rehearsal</a:t>
+            </a:r>
+            <a:r>
+              <a:rPr sz="2460" b="0" i="0">
+                <a:solidFill>
+                  <a:srgbClr val="0B0B0B"/>
+                </a:solidFill>
+                <a:latin typeface="Arial"/>
+              </a:rPr>
+              <a:t> </a:t>
+            </a:r>
+            <a:r>
+              <a:rPr sz="2460" b="0" i="0">
+                <a:solidFill>
+                  <a:srgbClr val="0B0B0B"/>
+                </a:solidFill>
+                <a:latin typeface="Arial"/>
+              </a:rPr>
+              <a:t>predicted</a:t>
+            </a:r>
+            <a:r>
+              <a:rPr sz="2460" b="0" i="0">
+                <a:solidFill>
+                  <a:srgbClr val="0B0B0B"/>
+                </a:solidFill>
+                <a:latin typeface="Arial"/>
+              </a:rPr>
+              <a:t> </a:t>
+            </a:r>
+            <a:r>
+              <a:rPr sz="2460" b="0" i="0">
+                <a:solidFill>
+                  <a:srgbClr val="0B0B0B"/>
+                </a:solidFill>
+                <a:latin typeface="Arial"/>
+              </a:rPr>
+              <a:t>(no</a:t>
+            </a:r>
+            <a:r>
+              <a:rPr sz="2460" b="0" i="0">
+                <a:solidFill>
+                  <a:srgbClr val="0B0B0B"/>
+                </a:solidFill>
+                <a:latin typeface="Arial"/>
+              </a:rPr>
+              <a:t> </a:t>
+            </a:r>
+            <a:r>
+              <a:rPr sz="2460" b="0" i="0">
+                <a:solidFill>
+                  <a:srgbClr val="0B0B0B"/>
+                </a:solidFill>
+                <a:latin typeface="Arial"/>
+              </a:rPr>
+              <a:t>new</a:t>
             </a:r>
           </a:p>
         </p:txBody>
@@ -15596,8 +15452,8 @@
         </p:nvSpPr>
         <p:spPr>
           <a:xfrm>
-            <a:off x="20775739" y="34386670"/>
-            <a:ext cx="8620714" cy="360595"/>
+            <a:off x="20775739" y="31998828"/>
+            <a:ext cx="8620648" cy="312517"/>
           </a:xfrm>
           <a:prstGeom prst="rect">
             <a:avLst/>
@@ -15611,157 +15467,175 @@
           <a:lstStyle/>
           <a:p>
             <a:r>
-              <a:rPr sz="2840" b="0" i="0">
-                <a:solidFill>
-                  <a:srgbClr val="0B0B0B"/>
-                </a:solidFill>
-                <a:latin typeface="Arial"/>
-              </a:rPr>
-              <a:t>Can</a:t>
-            </a:r>
-            <a:r>
-              <a:rPr sz="2840" b="0" i="0">
-                <a:solidFill>
-                  <a:srgbClr val="0B0B0B"/>
-                </a:solidFill>
-                <a:latin typeface="Arial"/>
-              </a:rPr>
-              <a:t> </a:t>
-            </a:r>
-            <a:r>
-              <a:rPr sz="2840" b="0" i="0">
-                <a:solidFill>
-                  <a:srgbClr val="0B0B0B"/>
-                </a:solidFill>
-                <a:latin typeface="Arial"/>
-              </a:rPr>
-              <a:t>a</a:t>
-            </a:r>
-            <a:r>
-              <a:rPr sz="2840" b="0" i="0">
-                <a:solidFill>
-                  <a:srgbClr val="0B0B0B"/>
-                </a:solidFill>
-                <a:latin typeface="Arial"/>
-              </a:rPr>
-              <a:t> </a:t>
-            </a:r>
-            <a:r>
-              <a:rPr sz="2840" b="0" i="0">
-                <a:solidFill>
-                  <a:srgbClr val="0B0B0B"/>
-                </a:solidFill>
-                <a:latin typeface="Arial"/>
-              </a:rPr>
-              <a:t>reasoning</a:t>
-            </a:r>
-            <a:r>
-              <a:rPr sz="2840" b="0" i="0">
-                <a:solidFill>
-                  <a:srgbClr val="0B0B0B"/>
-                </a:solidFill>
-                <a:latin typeface="Arial"/>
-              </a:rPr>
-              <a:t> </a:t>
-            </a:r>
-            <a:r>
-              <a:rPr sz="2840" b="0" i="0">
-                <a:solidFill>
-                  <a:srgbClr val="0B0B0B"/>
-                </a:solidFill>
-                <a:latin typeface="Arial"/>
-              </a:rPr>
-              <a:t>system</a:t>
-            </a:r>
-            <a:r>
-              <a:rPr sz="2840" b="0" i="0">
-                <a:solidFill>
-                  <a:srgbClr val="0B0B0B"/>
-                </a:solidFill>
-                <a:latin typeface="Arial"/>
-              </a:rPr>
-              <a:t> </a:t>
-            </a:r>
-            <a:r>
-              <a:rPr sz="2840" b="0" i="0">
-                <a:solidFill>
-                  <a:srgbClr val="0B0B0B"/>
-                </a:solidFill>
-                <a:latin typeface="Arial"/>
-              </a:rPr>
-              <a:t>learn</a:t>
-            </a:r>
-            <a:r>
-              <a:rPr sz="2840" b="0" i="0">
-                <a:solidFill>
-                  <a:srgbClr val="0B0B0B"/>
-                </a:solidFill>
-                <a:latin typeface="Arial"/>
-              </a:rPr>
-              <a:t> </a:t>
-            </a:r>
-            <a:r>
-              <a:rPr sz="2840" b="0" i="0">
-                <a:solidFill>
-                  <a:srgbClr val="0B0B0B"/>
-                </a:solidFill>
-                <a:latin typeface="Arial"/>
-              </a:rPr>
-              <a:t>from</a:t>
-            </a:r>
-            <a:r>
-              <a:rPr sz="2840" b="0" i="0">
-                <a:solidFill>
-                  <a:srgbClr val="0B0B0B"/>
-                </a:solidFill>
-                <a:latin typeface="Arial"/>
-              </a:rPr>
-              <a:t> </a:t>
-            </a:r>
-            <a:r>
-              <a:rPr sz="2840" b="0" i="0">
-                <a:solidFill>
-                  <a:srgbClr val="0B0B0B"/>
-                </a:solidFill>
-                <a:latin typeface="Arial"/>
-              </a:rPr>
-              <a:t>the</a:t>
-            </a:r>
-            <a:r>
-              <a:rPr sz="2840" b="0" i="0">
-                <a:solidFill>
-                  <a:srgbClr val="0B0B0B"/>
-                </a:solidFill>
-                <a:latin typeface="Arial"/>
-              </a:rPr>
-              <a:t> </a:t>
-            </a:r>
-            <a:r>
-              <a:rPr sz="2840" b="0" i="0">
-                <a:solidFill>
-                  <a:srgbClr val="0B0B0B"/>
-                </a:solidFill>
-                <a:latin typeface="Arial"/>
-              </a:rPr>
-              <a:t>boundary</a:t>
-            </a:r>
-            <a:r>
-              <a:rPr sz="2840" b="0" i="0">
-                <a:solidFill>
-                  <a:srgbClr val="0B0B0B"/>
-                </a:solidFill>
-                <a:latin typeface="Arial"/>
-              </a:rPr>
-              <a:t> </a:t>
-            </a:r>
-            <a:r>
-              <a:rPr sz="2840" b="0" i="0">
-                <a:solidFill>
-                  <a:srgbClr val="0B0B0B"/>
-                </a:solidFill>
-                <a:latin typeface="Arial"/>
-              </a:rPr>
-              <a:t>be-</a:t>
+              <a:rPr sz="2460" b="0" i="0">
+                <a:solidFill>
+                  <a:srgbClr val="0B0B0B"/>
+                </a:solidFill>
+                <a:latin typeface="Arial"/>
+              </a:rPr>
+              <a:t>answer</a:t>
+            </a:r>
+            <a:r>
+              <a:rPr sz="2460" b="0" i="0">
+                <a:solidFill>
+                  <a:srgbClr val="0B0B0B"/>
+                </a:solidFill>
+                <a:latin typeface="Arial"/>
+              </a:rPr>
+              <a:t> </a:t>
+            </a:r>
+            <a:r>
+              <a:rPr sz="2460" b="0" i="0">
+                <a:solidFill>
+                  <a:srgbClr val="0B0B0B"/>
+                </a:solidFill>
+                <a:latin typeface="Arial"/>
+              </a:rPr>
+              <a:t>committed).</a:t>
+            </a:r>
+            <a:r>
+              <a:rPr sz="2460" b="0" i="0">
+                <a:solidFill>
+                  <a:srgbClr val="0B0B0B"/>
+                </a:solidFill>
+                <a:latin typeface="Arial"/>
+              </a:rPr>
+              <a:t> </a:t>
+            </a:r>
+            <a:r>
+              <a:rPr sz="2460" b="0" i="0">
+                <a:solidFill>
+                  <a:srgbClr val="0B0B0B"/>
+                </a:solidFill>
+                <a:latin typeface="Arial"/>
+              </a:rPr>
+              <a:t>The</a:t>
+            </a:r>
+            <a:r>
+              <a:rPr sz="2460" b="0" i="0">
+                <a:solidFill>
+                  <a:srgbClr val="0B0B0B"/>
+                </a:solidFill>
+                <a:latin typeface="Arial"/>
+              </a:rPr>
+              <a:t> </a:t>
+            </a:r>
+            <a:r>
+              <a:rPr sz="2460" b="0" i="0">
+                <a:solidFill>
+                  <a:srgbClr val="0B0B0B"/>
+                </a:solidFill>
+                <a:latin typeface="Arial"/>
+              </a:rPr>
+              <a:t>guarded</a:t>
+            </a:r>
+            <a:r>
+              <a:rPr sz="2460" b="0" i="0">
+                <a:solidFill>
+                  <a:srgbClr val="0B0B0B"/>
+                </a:solidFill>
+                <a:latin typeface="Arial"/>
+              </a:rPr>
+              <a:t> </a:t>
+            </a:r>
+            <a:r>
+              <a:rPr sz="2460" b="0" i="0">
+                <a:solidFill>
+                  <a:srgbClr val="0B0B0B"/>
+                </a:solidFill>
+                <a:latin typeface="Arial"/>
+              </a:rPr>
+              <a:t>rule</a:t>
+            </a:r>
+            <a:r>
+              <a:rPr sz="2460" b="0" i="0">
+                <a:solidFill>
+                  <a:srgbClr val="0B0B0B"/>
+                </a:solidFill>
+                <a:latin typeface="Arial"/>
+              </a:rPr>
+              <a:t> </a:t>
+            </a:r>
+            <a:r>
+              <a:rPr sz="2460" b="0" i="0">
+                <a:solidFill>
+                  <a:srgbClr val="0B0B0B"/>
+                </a:solidFill>
+                <a:latin typeface="Arial"/>
+              </a:rPr>
+              <a:t>came</a:t>
+            </a:r>
+            <a:r>
+              <a:rPr sz="2460" b="0" i="0">
+                <a:solidFill>
+                  <a:srgbClr val="0B0B0B"/>
+                </a:solidFill>
+                <a:latin typeface="Arial"/>
+              </a:rPr>
+              <a:t> </a:t>
+            </a:r>
+            <a:r>
+              <a:rPr sz="2460" b="0" i="0">
+                <a:solidFill>
+                  <a:srgbClr val="0B0B0B"/>
+                </a:solidFill>
+                <a:latin typeface="Arial"/>
+              </a:rPr>
+              <a:t>later</a:t>
+            </a:r>
+            <a:r>
+              <a:rPr sz="2460" b="0" i="0">
+                <a:solidFill>
+                  <a:srgbClr val="0B0B0B"/>
+                </a:solidFill>
+                <a:latin typeface="Arial"/>
+              </a:rPr>
+              <a:t> </a:t>
+            </a:r>
+            <a:r>
+              <a:rPr sz="2460" b="0" i="0">
+                <a:solidFill>
+                  <a:srgbClr val="0B0B0B"/>
+                </a:solidFill>
+                <a:latin typeface="Arial"/>
+              </a:rPr>
+              <a:t>and</a:t>
+            </a:r>
+            <a:r>
+              <a:rPr sz="2460" b="0" i="0">
+                <a:solidFill>
+                  <a:srgbClr val="0B0B0B"/>
+                </a:solidFill>
+                <a:latin typeface="Arial"/>
+              </a:rPr>
+              <a:t> </a:t>
+            </a:r>
+            <a:r>
+              <a:rPr sz="2460" b="0" i="0">
+                <a:solidFill>
+                  <a:srgbClr val="0B0B0B"/>
+                </a:solidFill>
+                <a:latin typeface="Arial"/>
+              </a:rPr>
+              <a:t>is</a:t>
+            </a:r>
+            <a:r>
+              <a:rPr sz="2460" b="0" i="0">
+                <a:solidFill>
+                  <a:srgbClr val="0B0B0B"/>
+                </a:solidFill>
+                <a:latin typeface="Arial"/>
+              </a:rPr>
+              <a:t> </a:t>
+            </a:r>
+            <a:r>
+              <a:rPr sz="2460" b="0" i="0">
+                <a:solidFill>
+                  <a:srgbClr val="0B0B0B"/>
+                </a:solidFill>
+                <a:latin typeface="Arial"/>
+              </a:rPr>
+              <a:t>not</a:t>
             </a:r>
           </a:p>
         </p:txBody>
@@ -15774,8 +15648,8 @@
         </p:nvSpPr>
         <p:spPr>
           <a:xfrm>
-            <a:off x="20775739" y="34854818"/>
-            <a:ext cx="8620711" cy="360595"/>
+            <a:off x="20775739" y="32403705"/>
+            <a:ext cx="1279306" cy="312517"/>
           </a:xfrm>
           <a:prstGeom prst="rect">
             <a:avLst/>
@@ -15789,13 +15663,13 @@
           <a:lstStyle/>
           <a:p>
             <a:r>
-              <a:rPr sz="2840" b="0" i="0">
-                <a:solidFill>
-                  <a:srgbClr val="0B0B0B"/>
-                </a:solidFill>
-                <a:latin typeface="Arial"/>
-              </a:rPr>
-              <a:t>tween what its current knowledge explains and what it</a:t>
+              <a:rPr sz="2460" b="0" i="0">
+                <a:solidFill>
+                  <a:srgbClr val="0B0B0B"/>
+                </a:solidFill>
+                <a:latin typeface="Arial"/>
+              </a:rPr>
+              <a:t>part of it.</a:t>
             </a:r>
           </a:p>
         </p:txBody>
@@ -15808,8 +15682,8 @@
         </p:nvSpPr>
         <p:spPr>
           <a:xfrm>
-            <a:off x="20775739" y="35322963"/>
-            <a:ext cx="8620711" cy="360595"/>
+            <a:off x="20775739" y="33953626"/>
+            <a:ext cx="6855984" cy="480795"/>
           </a:xfrm>
           <a:prstGeom prst="rect">
             <a:avLst/>
@@ -15823,13 +15697,13 @@
           <a:lstStyle/>
           <a:p>
             <a:r>
-              <a:rPr sz="2840" b="0" i="0">
-                <a:solidFill>
-                  <a:srgbClr val="0B0B0B"/>
-                </a:solidFill>
-                <a:latin typeface="Arial"/>
-              </a:rPr>
-              <a:t>cannot, decide what must change, and acquire a capa-</a:t>
+              <a:rPr sz="3790" b="1" i="0">
+                <a:solidFill>
+                  <a:srgbClr val="2A78D6"/>
+                </a:solidFill>
+                <a:latin typeface="Arial"/>
+              </a:rPr>
+              <a:t>The question I want to pursue</a:t>
             </a:r>
           </a:p>
         </p:txBody>
@@ -15842,8 +15716,8 @@
         </p:nvSpPr>
         <p:spPr>
           <a:xfrm>
-            <a:off x="20775739" y="35791099"/>
-            <a:ext cx="8620711" cy="360595"/>
+            <a:off x="20775739" y="35130497"/>
+            <a:ext cx="8620714" cy="360595"/>
           </a:xfrm>
           <a:prstGeom prst="rect">
             <a:avLst/>
@@ -15863,79 +15737,7 @@
                 </a:solidFill>
                 <a:latin typeface="Arial"/>
               </a:rPr>
-              <a:t>bility</a:t>
-            </a:r>
-            <a:r>
-              <a:rPr sz="2840" b="0" i="0">
-                <a:solidFill>
-                  <a:srgbClr val="0B0B0B"/>
-                </a:solidFill>
-                <a:latin typeface="Arial"/>
-              </a:rPr>
-              <a:t> </a:t>
-            </a:r>
-            <a:r>
-              <a:rPr sz="2840" b="0" i="0">
-                <a:solidFill>
-                  <a:srgbClr val="0B0B0B"/>
-                </a:solidFill>
-                <a:latin typeface="Arial"/>
-              </a:rPr>
-              <a:t>that</a:t>
-            </a:r>
-            <a:r>
-              <a:rPr sz="2840" b="0" i="0">
-                <a:solidFill>
-                  <a:srgbClr val="0B0B0B"/>
-                </a:solidFill>
-                <a:latin typeface="Arial"/>
-              </a:rPr>
-              <a:t> </a:t>
-            </a:r>
-            <a:r>
-              <a:rPr sz="2840" b="0" i="0">
-                <a:solidFill>
-                  <a:srgbClr val="0B0B0B"/>
-                </a:solidFill>
-                <a:latin typeface="Arial"/>
-              </a:rPr>
-              <a:t>generalizes?</a:t>
-            </a:r>
-            <a:r>
-              <a:rPr sz="2840" b="0" i="0">
-                <a:solidFill>
-                  <a:srgbClr val="0B0B0B"/>
-                </a:solidFill>
-                <a:latin typeface="Arial"/>
-              </a:rPr>
-              <a:t> </a:t>
-            </a:r>
-            <a:r>
-              <a:rPr sz="2840" b="0" i="0">
-                <a:solidFill>
-                  <a:srgbClr val="0B0B0B"/>
-                </a:solidFill>
-                <a:latin typeface="Arial"/>
-              </a:rPr>
-              <a:t>ARC</a:t>
-            </a:r>
-            <a:r>
-              <a:rPr sz="2840" b="0" i="0">
-                <a:solidFill>
-                  <a:srgbClr val="0B0B0B"/>
-                </a:solidFill>
-                <a:latin typeface="Arial"/>
-              </a:rPr>
-              <a:t> </a:t>
-            </a:r>
-            <a:r>
-              <a:rPr sz="2840" b="0" i="0">
-                <a:solidFill>
-                  <a:srgbClr val="0B0B0B"/>
-                </a:solidFill>
-                <a:latin typeface="Arial"/>
-              </a:rPr>
-              <a:t>offers</a:t>
+              <a:t>Can</a:t>
             </a:r>
             <a:r>
               <a:rPr sz="2840" b="0" i="0">
@@ -15971,25 +15773,115 @@
                 </a:solidFill>
                 <a:latin typeface="Arial"/>
               </a:rPr>
-              <a:t>controlled</a:t>
-            </a:r>
-            <a:r>
-              <a:rPr sz="2840" b="0" i="0">
-                <a:solidFill>
-                  <a:srgbClr val="0B0B0B"/>
-                </a:solidFill>
-                <a:latin typeface="Arial"/>
-              </a:rPr>
-              <a:t> </a:t>
-            </a:r>
-            <a:r>
-              <a:rPr sz="2840" b="0" i="0">
-                <a:solidFill>
-                  <a:srgbClr val="0B0B0B"/>
-                </a:solidFill>
-                <a:latin typeface="Arial"/>
-              </a:rPr>
-              <a:t>place</a:t>
+              <a:t>reasoning</a:t>
+            </a:r>
+            <a:r>
+              <a:rPr sz="2840" b="0" i="0">
+                <a:solidFill>
+                  <a:srgbClr val="0B0B0B"/>
+                </a:solidFill>
+                <a:latin typeface="Arial"/>
+              </a:rPr>
+              <a:t> </a:t>
+            </a:r>
+            <a:r>
+              <a:rPr sz="2840" b="0" i="0">
+                <a:solidFill>
+                  <a:srgbClr val="0B0B0B"/>
+                </a:solidFill>
+                <a:latin typeface="Arial"/>
+              </a:rPr>
+              <a:t>system</a:t>
+            </a:r>
+            <a:r>
+              <a:rPr sz="2840" b="0" i="0">
+                <a:solidFill>
+                  <a:srgbClr val="0B0B0B"/>
+                </a:solidFill>
+                <a:latin typeface="Arial"/>
+              </a:rPr>
+              <a:t> </a:t>
+            </a:r>
+            <a:r>
+              <a:rPr sz="2840" b="0" i="0">
+                <a:solidFill>
+                  <a:srgbClr val="0B0B0B"/>
+                </a:solidFill>
+                <a:latin typeface="Arial"/>
+              </a:rPr>
+              <a:t>learn</a:t>
+            </a:r>
+            <a:r>
+              <a:rPr sz="2840" b="0" i="0">
+                <a:solidFill>
+                  <a:srgbClr val="0B0B0B"/>
+                </a:solidFill>
+                <a:latin typeface="Arial"/>
+              </a:rPr>
+              <a:t> </a:t>
+            </a:r>
+            <a:r>
+              <a:rPr sz="2840" b="0" i="0">
+                <a:solidFill>
+                  <a:srgbClr val="0B0B0B"/>
+                </a:solidFill>
+                <a:latin typeface="Arial"/>
+              </a:rPr>
+              <a:t>from</a:t>
+            </a:r>
+            <a:r>
+              <a:rPr sz="2840" b="0" i="0">
+                <a:solidFill>
+                  <a:srgbClr val="0B0B0B"/>
+                </a:solidFill>
+                <a:latin typeface="Arial"/>
+              </a:rPr>
+              <a:t> </a:t>
+            </a:r>
+            <a:r>
+              <a:rPr sz="2840" b="0" i="0">
+                <a:solidFill>
+                  <a:srgbClr val="0B0B0B"/>
+                </a:solidFill>
+                <a:latin typeface="Arial"/>
+              </a:rPr>
+              <a:t>the</a:t>
+            </a:r>
+            <a:r>
+              <a:rPr sz="2840" b="0" i="0">
+                <a:solidFill>
+                  <a:srgbClr val="0B0B0B"/>
+                </a:solidFill>
+                <a:latin typeface="Arial"/>
+              </a:rPr>
+              <a:t> </a:t>
+            </a:r>
+            <a:r>
+              <a:rPr sz="2840" b="0" i="0">
+                <a:solidFill>
+                  <a:srgbClr val="0B0B0B"/>
+                </a:solidFill>
+                <a:latin typeface="Arial"/>
+              </a:rPr>
+              <a:t>boundary</a:t>
+            </a:r>
+            <a:r>
+              <a:rPr sz="2840" b="0" i="0">
+                <a:solidFill>
+                  <a:srgbClr val="0B0B0B"/>
+                </a:solidFill>
+                <a:latin typeface="Arial"/>
+              </a:rPr>
+              <a:t> </a:t>
+            </a:r>
+            <a:r>
+              <a:rPr sz="2840" b="0" i="0">
+                <a:solidFill>
+                  <a:srgbClr val="0B0B0B"/>
+                </a:solidFill>
+                <a:latin typeface="Arial"/>
+              </a:rPr>
+              <a:t>be-</a:t>
             </a:r>
           </a:p>
         </p:txBody>
@@ -16002,8 +15894,8 @@
         </p:nvSpPr>
         <p:spPr>
           <a:xfrm>
-            <a:off x="20775739" y="36259247"/>
-            <a:ext cx="5987643" cy="360595"/>
+            <a:off x="20775739" y="35598630"/>
+            <a:ext cx="8620711" cy="360595"/>
           </a:xfrm>
           <a:prstGeom prst="rect">
             <a:avLst/>
@@ -16023,7 +15915,7 @@
                 </a:solidFill>
                 <a:latin typeface="Arial"/>
               </a:rPr>
-              <a:t>to find out before testing it in science.</a:t>
+              <a:t>tween what its current knowledge explains and what it</a:t>
             </a:r>
           </a:p>
         </p:txBody>
@@ -16036,8 +15928,8 @@
         </p:nvSpPr>
         <p:spPr>
           <a:xfrm>
-            <a:off x="20775739" y="36783057"/>
-            <a:ext cx="4651232" cy="264439"/>
+            <a:off x="20775739" y="36066778"/>
+            <a:ext cx="8620711" cy="360595"/>
           </a:xfrm>
           <a:prstGeom prst="rect">
             <a:avLst/>
@@ -16051,13 +15943,13 @@
           <a:lstStyle/>
           <a:p>
             <a:r>
-              <a:rPr sz="2080" b="0" i="0">
-                <a:solidFill>
-                  <a:srgbClr val="0B0B0B"/>
-                </a:solidFill>
-                <a:latin typeface="Arial"/>
-              </a:rPr>
-              <a:t>Every number, with its scope and hash:</a:t>
+              <a:rPr sz="2840" b="0" i="0">
+                <a:solidFill>
+                  <a:srgbClr val="0B0B0B"/>
+                </a:solidFill>
+                <a:latin typeface="Arial"/>
+              </a:rPr>
+              <a:t>cannot, decide what must change, and acquire a capa-</a:t>
             </a:r>
           </a:p>
         </p:txBody>
@@ -16070,8 +15962,8 @@
         </p:nvSpPr>
         <p:spPr>
           <a:xfrm>
-            <a:off x="20775739" y="37124059"/>
-            <a:ext cx="8281215" cy="278358"/>
+            <a:off x="20775739" y="36534926"/>
+            <a:ext cx="8620711" cy="360595"/>
           </a:xfrm>
           <a:prstGeom prst="rect">
             <a:avLst/>
@@ -16085,40 +15977,139 @@
           <a:lstStyle/>
           <a:p>
             <a:r>
-              <a:rPr sz="2190" b="0" i="0">
-                <a:solidFill>
-                  <a:srgbClr val="0B0B0B"/>
-                </a:solidFill>
-                <a:latin typeface="Courier New"/>
-              </a:rPr>
-              <a:t>records/CORA_SUMMIT_CLAIM_LEDGER_20261017.md</a:t>
-            </a:r>
-            <a:r>
-              <a:rPr sz="2080" b="0" i="0">
-                <a:solidFill>
-                  <a:srgbClr val="0B0B0B"/>
-                </a:solidFill>
-                <a:latin typeface="Arial"/>
-              </a:rPr>
-              <a:t>.</a:t>
-            </a:r>
-            <a:r>
-              <a:rPr sz="2080" b="0" i="0">
-                <a:solidFill>
-                  <a:srgbClr val="0B0B0B"/>
-                </a:solidFill>
-                <a:latin typeface="Arial"/>
-              </a:rPr>
-              <a:t> </a:t>
-            </a:r>
-            <a:r>
-              <a:rPr sz="2080" b="0" i="0">
-                <a:solidFill>
-                  <a:srgbClr val="0B0B0B"/>
-                </a:solidFill>
-                <a:latin typeface="Arial"/>
-              </a:rPr>
-              <a:t>Authorship and</a:t>
+              <a:rPr sz="2840" b="0" i="0">
+                <a:solidFill>
+                  <a:srgbClr val="0B0B0B"/>
+                </a:solidFill>
+                <a:latin typeface="Arial"/>
+              </a:rPr>
+              <a:t>bility</a:t>
+            </a:r>
+            <a:r>
+              <a:rPr sz="2840" b="0" i="0">
+                <a:solidFill>
+                  <a:srgbClr val="0B0B0B"/>
+                </a:solidFill>
+                <a:latin typeface="Arial"/>
+              </a:rPr>
+              <a:t> </a:t>
+            </a:r>
+            <a:r>
+              <a:rPr sz="2840" b="0" i="0">
+                <a:solidFill>
+                  <a:srgbClr val="0B0B0B"/>
+                </a:solidFill>
+                <a:latin typeface="Arial"/>
+              </a:rPr>
+              <a:t>that</a:t>
+            </a:r>
+            <a:r>
+              <a:rPr sz="2840" b="0" i="0">
+                <a:solidFill>
+                  <a:srgbClr val="0B0B0B"/>
+                </a:solidFill>
+                <a:latin typeface="Arial"/>
+              </a:rPr>
+              <a:t> </a:t>
+            </a:r>
+            <a:r>
+              <a:rPr sz="2840" b="0" i="0">
+                <a:solidFill>
+                  <a:srgbClr val="0B0B0B"/>
+                </a:solidFill>
+                <a:latin typeface="Arial"/>
+              </a:rPr>
+              <a:t>generalizes?</a:t>
+            </a:r>
+            <a:r>
+              <a:rPr sz="2840" b="0" i="0">
+                <a:solidFill>
+                  <a:srgbClr val="0B0B0B"/>
+                </a:solidFill>
+                <a:latin typeface="Arial"/>
+              </a:rPr>
+              <a:t> </a:t>
+            </a:r>
+            <a:r>
+              <a:rPr sz="2840" b="0" i="0">
+                <a:solidFill>
+                  <a:srgbClr val="0B0B0B"/>
+                </a:solidFill>
+                <a:latin typeface="Arial"/>
+              </a:rPr>
+              <a:t>ARC</a:t>
+            </a:r>
+            <a:r>
+              <a:rPr sz="2840" b="0" i="0">
+                <a:solidFill>
+                  <a:srgbClr val="0B0B0B"/>
+                </a:solidFill>
+                <a:latin typeface="Arial"/>
+              </a:rPr>
+              <a:t> </a:t>
+            </a:r>
+            <a:r>
+              <a:rPr sz="2840" b="0" i="0">
+                <a:solidFill>
+                  <a:srgbClr val="0B0B0B"/>
+                </a:solidFill>
+                <a:latin typeface="Arial"/>
+              </a:rPr>
+              <a:t>offers</a:t>
+            </a:r>
+            <a:r>
+              <a:rPr sz="2840" b="0" i="0">
+                <a:solidFill>
+                  <a:srgbClr val="0B0B0B"/>
+                </a:solidFill>
+                <a:latin typeface="Arial"/>
+              </a:rPr>
+              <a:t> </a:t>
+            </a:r>
+            <a:r>
+              <a:rPr sz="2840" b="0" i="0">
+                <a:solidFill>
+                  <a:srgbClr val="0B0B0B"/>
+                </a:solidFill>
+                <a:latin typeface="Arial"/>
+              </a:rPr>
+              <a:t>a</a:t>
+            </a:r>
+            <a:r>
+              <a:rPr sz="2840" b="0" i="0">
+                <a:solidFill>
+                  <a:srgbClr val="0B0B0B"/>
+                </a:solidFill>
+                <a:latin typeface="Arial"/>
+              </a:rPr>
+              <a:t> </a:t>
+            </a:r>
+            <a:r>
+              <a:rPr sz="2840" b="0" i="0">
+                <a:solidFill>
+                  <a:srgbClr val="0B0B0B"/>
+                </a:solidFill>
+                <a:latin typeface="Arial"/>
+              </a:rPr>
+              <a:t>controlled</a:t>
+            </a:r>
+            <a:r>
+              <a:rPr sz="2840" b="0" i="0">
+                <a:solidFill>
+                  <a:srgbClr val="0B0B0B"/>
+                </a:solidFill>
+                <a:latin typeface="Arial"/>
+              </a:rPr>
+              <a:t> </a:t>
+            </a:r>
+            <a:r>
+              <a:rPr sz="2840" b="0" i="0">
+                <a:solidFill>
+                  <a:srgbClr val="0B0B0B"/>
+                </a:solidFill>
+                <a:latin typeface="Arial"/>
+              </a:rPr>
+              <a:t>place</a:t>
             </a:r>
           </a:p>
         </p:txBody>
@@ -16131,7 +16122,136 @@
         </p:nvSpPr>
         <p:spPr>
           <a:xfrm>
-            <a:off x="20775739" y="37466305"/>
+            <a:off x="20775739" y="37003074"/>
+            <a:ext cx="5987643" cy="360595"/>
+          </a:xfrm>
+          <a:prstGeom prst="rect">
+            <a:avLst/>
+          </a:prstGeom>
+          <a:noFill/>
+        </p:spPr>
+        <p:txBody>
+          <a:bodyPr wrap="none" lIns="0" rIns="0" tIns="0" bIns="0">
+            <a:spAutoFit/>
+          </a:bodyPr>
+          <a:lstStyle/>
+          <a:p>
+            <a:r>
+              <a:rPr sz="2840" b="0" i="0">
+                <a:solidFill>
+                  <a:srgbClr val="0B0B0B"/>
+                </a:solidFill>
+                <a:latin typeface="Arial"/>
+              </a:rPr>
+              <a:t>to find out before testing it in science.</a:t>
+            </a:r>
+          </a:p>
+        </p:txBody>
+      </p:sp>
+      <p:sp>
+        <p:nvSpPr>
+          <p:cNvPr id="157" name="TextBox 156"/>
+          <p:cNvSpPr txBox="1"/>
+          <p:nvPr/>
+        </p:nvSpPr>
+        <p:spPr>
+          <a:xfrm>
+            <a:off x="20775739" y="37526884"/>
+            <a:ext cx="4651232" cy="264439"/>
+          </a:xfrm>
+          <a:prstGeom prst="rect">
+            <a:avLst/>
+          </a:prstGeom>
+          <a:noFill/>
+        </p:spPr>
+        <p:txBody>
+          <a:bodyPr wrap="none" lIns="0" rIns="0" tIns="0" bIns="0">
+            <a:spAutoFit/>
+          </a:bodyPr>
+          <a:lstStyle/>
+          <a:p>
+            <a:r>
+              <a:rPr sz="2080" b="0" i="0">
+                <a:solidFill>
+                  <a:srgbClr val="0B0B0B"/>
+                </a:solidFill>
+                <a:latin typeface="Arial"/>
+              </a:rPr>
+              <a:t>Every number, with its scope and hash:</a:t>
+            </a:r>
+          </a:p>
+        </p:txBody>
+      </p:sp>
+      <p:sp>
+        <p:nvSpPr>
+          <p:cNvPr id="158" name="TextBox 157"/>
+          <p:cNvSpPr txBox="1"/>
+          <p:nvPr/>
+        </p:nvSpPr>
+        <p:spPr>
+          <a:xfrm>
+            <a:off x="20775739" y="37867874"/>
+            <a:ext cx="8281215" cy="278358"/>
+          </a:xfrm>
+          <a:prstGeom prst="rect">
+            <a:avLst/>
+          </a:prstGeom>
+          <a:noFill/>
+        </p:spPr>
+        <p:txBody>
+          <a:bodyPr wrap="none" lIns="0" rIns="0" tIns="0" bIns="0">
+            <a:spAutoFit/>
+          </a:bodyPr>
+          <a:lstStyle/>
+          <a:p>
+            <a:r>
+              <a:rPr sz="2190" b="0" i="0">
+                <a:solidFill>
+                  <a:srgbClr val="0B0B0B"/>
+                </a:solidFill>
+                <a:latin typeface="Courier New"/>
+              </a:rPr>
+              <a:t>records/CORA_SUMMIT_CLAIM_LEDGER_20261017.md</a:t>
+            </a:r>
+            <a:r>
+              <a:rPr sz="2080" b="0" i="0">
+                <a:solidFill>
+                  <a:srgbClr val="0B0B0B"/>
+                </a:solidFill>
+                <a:latin typeface="Arial"/>
+              </a:rPr>
+              <a:t>.</a:t>
+            </a:r>
+            <a:r>
+              <a:rPr sz="2080" b="0" i="0">
+                <a:solidFill>
+                  <a:srgbClr val="0B0B0B"/>
+                </a:solidFill>
+                <a:latin typeface="Arial"/>
+              </a:rPr>
+              <a:t> </a:t>
+            </a:r>
+            <a:r>
+              <a:rPr sz="2080" b="0" i="0">
+                <a:solidFill>
+                  <a:srgbClr val="0B0B0B"/>
+                </a:solidFill>
+                <a:latin typeface="Arial"/>
+              </a:rPr>
+              <a:t>Authorship and</a:t>
+            </a:r>
+          </a:p>
+        </p:txBody>
+      </p:sp>
+      <p:sp>
+        <p:nvSpPr>
+          <p:cNvPr id="159" name="TextBox 158"/>
+          <p:cNvSpPr txBox="1"/>
+          <p:nvPr/>
+        </p:nvSpPr>
+        <p:spPr>
+          <a:xfrm>
+            <a:off x="20775739" y="38210117"/>
             <a:ext cx="4633788" cy="264439"/>
           </a:xfrm>
           <a:prstGeom prst="rect">

</xml_diff>